<commit_message>
Demo deck: one slide per script paragraph (12 slides); script organised by slide
Co-Authored-By: Claude Opus 5.5 <noreply@anthropic.com>
Claude-Session: https://claude.ai/code/session_012DQUA9R3J3x1wc2DhTfH11
</commit_message>
<xml_diff>
--- a/docs/demo_slides.pptx
+++ b/docs/demo_slides.pptx
@@ -15,6 +15,8 @@
     <p:sldId id="263" r:id="rId15"/>
     <p:sldId id="264" r:id="rId16"/>
     <p:sldId id="265" r:id="rId17"/>
+    <p:sldId id="266" r:id="rId18"/>
+    <p:sldId id="267" r:id="rId19"/>
   </p:sldIdLst>
   <p:sldSz cx="12191695" cy="6858000" type="screen4x3"/>
   <p:notesSz cx="6858000" cy="9144000"/>
@@ -581,7 +583,147 @@
           <a:lstStyle/>
           <a:p>
             <a:r>
-              <a:t>Everything runs with one command, `main`, from raw CSV to submission and figures. The code is modular functions with argument validation, unit tests in `matlab.unittest`, a validated submission file, and every number in our README is printed by MATLAB. Next steps: monthly meter data, occupancy, and optimising which retrofits to fund first. Thank you.</a:t>
+              <a:t>Then we turn predictions into action. A cold-start model predicts what a typical building of the same type, size, age and climate should use. Buildings far above that are retrofit candidates: 1,123 buildings, 5% of the stock, using 1.55 × 10¹⁰ kBtu a year more than expected. That's 5.3% of all energy used. They are ranked by absolute excess energy, so an organisation knows where a retrofit pays off most.</a:t>
+            </a:r>
+          </a:p>
+        </p:txBody>
+      </p:sp>
+      <p:sp>
+        <p:nvSpPr>
+          <p:cNvPr id="4" name="Slide Number Placeholder 3"/>
+          <p:cNvSpPr>
+            <a:spLocks noGrp="1"/>
+          </p:cNvSpPr>
+          <p:nvPr>
+            <p:ph type="sldNum" idx="5" sz="quarter"/>
+          </p:nvPr>
+        </p:nvSpPr>
+        <p:spPr/>
+      </p:sp>
+    </p:spTree>
+  </p:cSld>
+  <p:clrMapOvr>
+    <a:masterClrMapping/>
+  </p:clrMapOvr>
+</p:notes>
+</file>
+
+<file path=ppt/notesSlides/notesSlide11.xml><?xml version="1.0" encoding="utf-8"?>
+<p:notes xmlns:a="http://schemas.openxmlformats.org/drawingml/2006/main" xmlns:p="http://schemas.openxmlformats.org/presentationml/2006/main" xmlns:r="http://schemas.openxmlformats.org/officeDocument/2006/relationships">
+  <p:cSld>
+    <p:spTree>
+      <p:nvGrpSpPr>
+        <p:cNvPr id="1" name=""/>
+        <p:cNvGrpSpPr/>
+        <p:nvPr/>
+      </p:nvGrpSpPr>
+      <p:grpSpPr>
+        <a:xfrm>
+          <a:off x="0" y="0"/>
+          <a:ext cx="0" cy="0"/>
+          <a:chOff x="0" y="0"/>
+          <a:chExt cx="0" cy="0"/>
+        </a:xfrm>
+      </p:grpSpPr>
+      <p:sp>
+        <p:nvSpPr>
+          <p:cNvPr id="2" name="Slide Image Placeholder 1"/>
+          <p:cNvSpPr>
+            <a:spLocks noGrp="1"/>
+          </p:cNvSpPr>
+          <p:nvPr>
+            <p:ph type="sldImg" idx="2"/>
+          </p:nvPr>
+        </p:nvSpPr>
+        <p:spPr/>
+      </p:sp>
+      <p:sp>
+        <p:nvSpPr>
+          <p:cNvPr id="3" name="Notes Placeholder 2"/>
+          <p:cNvSpPr>
+            <a:spLocks noGrp="1"/>
+          </p:cNvSpPr>
+          <p:nvPr>
+            <p:ph type="body" idx="3" sz="quarter"/>
+          </p:nvPr>
+        </p:nvSpPr>
+        <p:spPr/>
+        <p:txBody>
+          <a:bodyPr/>
+          <a:lstStyle/>
+          <a:p>
+            <a:r>
+              <a:t>Everything runs with one command, main, from raw CSV to submission and figures. The code is modular functions with argument validation, unit tests in matlab.unittest, and a validated submission file. Every number in our README was printed by MATLAB.</a:t>
+            </a:r>
+          </a:p>
+        </p:txBody>
+      </p:sp>
+      <p:sp>
+        <p:nvSpPr>
+          <p:cNvPr id="4" name="Slide Number Placeholder 3"/>
+          <p:cNvSpPr>
+            <a:spLocks noGrp="1"/>
+          </p:cNvSpPr>
+          <p:nvPr>
+            <p:ph type="sldNum" idx="5" sz="quarter"/>
+          </p:nvPr>
+        </p:nvSpPr>
+        <p:spPr/>
+      </p:sp>
+    </p:spTree>
+  </p:cSld>
+  <p:clrMapOvr>
+    <a:masterClrMapping/>
+  </p:clrMapOvr>
+</p:notes>
+</file>
+
+<file path=ppt/notesSlides/notesSlide12.xml><?xml version="1.0" encoding="utf-8"?>
+<p:notes xmlns:a="http://schemas.openxmlformats.org/drawingml/2006/main" xmlns:p="http://schemas.openxmlformats.org/presentationml/2006/main" xmlns:r="http://schemas.openxmlformats.org/officeDocument/2006/relationships">
+  <p:cSld>
+    <p:spTree>
+      <p:nvGrpSpPr>
+        <p:cNvPr id="1" name=""/>
+        <p:cNvGrpSpPr/>
+        <p:nvPr/>
+      </p:nvGrpSpPr>
+      <p:grpSpPr>
+        <a:xfrm>
+          <a:off x="0" y="0"/>
+          <a:ext cx="0" cy="0"/>
+          <a:chOff x="0" y="0"/>
+          <a:chExt cx="0" cy="0"/>
+        </a:xfrm>
+      </p:grpSpPr>
+      <p:sp>
+        <p:nvSpPr>
+          <p:cNvPr id="2" name="Slide Image Placeholder 1"/>
+          <p:cNvSpPr>
+            <a:spLocks noGrp="1"/>
+          </p:cNvSpPr>
+          <p:nvPr>
+            <p:ph type="sldImg" idx="2"/>
+          </p:nvPr>
+        </p:nvSpPr>
+        <p:spPr/>
+      </p:sp>
+      <p:sp>
+        <p:nvSpPr>
+          <p:cNvPr id="3" name="Notes Placeholder 2"/>
+          <p:cNvSpPr>
+            <a:spLocks noGrp="1"/>
+          </p:cNvSpPr>
+          <p:nvPr>
+            <p:ph type="body" idx="3" sz="quarter"/>
+          </p:nvPr>
+        </p:nvSpPr>
+        <p:spPr/>
+        <p:txBody>
+          <a:bodyPr/>
+          <a:lstStyle/>
+          <a:p>
+            <a:r>
+              <a:t>Next steps: monthly meter data, occupancy, and optimising which retrofits to fund first. Thank you.</a:t>
             </a:r>
           </a:p>
         </p:txBody>
@@ -651,7 +793,7 @@
           <a:lstStyle/>
           <a:p>
             <a:r>
-              <a:t>Buildings are among the largest contributors to energy use and carbon emissions. To fix them we first need to know which buildings are wasting energy. Not which use the most, but which use more than they should, given what they are and where they are. That's what we built in MATLAB.</a:t>
+              <a:t>A building's heating energy follows an energy balance: Q ≈ UA·ΔT summed over the year. So we engineered degree-day and seasonal temperature features. In the raw data, median energy use is roughly 36 to 53 in milder climates and 68 to 82 in colder ones.</a:t>
             </a:r>
           </a:p>
         </p:txBody>
@@ -721,7 +863,7 @@
           <a:lstStyle/>
           <a:p>
             <a:r>
-              <a:t>(fig. 05 EUI vs HDD) "A building's heating energy follows an energy balance: Q ≈ UA·ΔT summed over the year. So we engineered degree-day and seasonal temperature features. In the raw data, median energy use is roughly 36–53 in milder climates and 68–82 in colder ones.</a:t>
+              <a:t>Before modelling we looked hard at the data. Three findings drove our design. One: State_6 is 67% of the training data and 0% of the test data. So besides the normal score, we report a 'test-like' score on non-State_6 buildings.</a:t>
             </a:r>
           </a:p>
         </p:txBody>
@@ -791,7 +933,7 @@
           <a:lstStyle/>
           <a:p>
             <a:r>
-              <a:t>(fig. 02 state shift, results/decisions.csv) "Before modelling we looked hard at the data. Three findings drove our design: 1. State_6 is 67% of the training data and *0%* of the test data. So besides the normal score we report a 'test-like' score on non-State_6 buildings. 2. The wind and fog columns are 56% missing in train but 90% in test. That's a missingness shift a model would wrongly learn from, so we dropped them. 3. The same buildings appear in several years without an id. We reconstructed one (63,907 buildings), so a building's *past* energy use becomes a feature. It is computed only from earlier years, and a unit test proves it.</a:t>
+              <a:t>Two: the wind and fog columns are 56% missing in train but 90% in test. A model would wrongly learn from that missingness shift, so we dropped them.</a:t>
             </a:r>
           </a:p>
         </p:txBody>
@@ -861,7 +1003,7 @@
           <a:lstStyle/>
           <a:p>
             <a:r>
-              <a:t>(fig. 06, fig. 09) "We validate the way the task works: train on years 1–5, predict year 6, never seen. Same model, a random split would have told us RMSE 37.9; the honest temporal split says 42.5. Then we climbed a ladder of 10 models, each answering one question: - linear regression 46.2, a single tree 40.9: interactions matter; - adding building history brought buildings with a track record down to RMSE 20; - blending raw- and log-scale boosted trees gave our best model: RMSE 37.6, 34% better than the naive baseline, R² 0.57. One MATLAB-specific lesson: MATLAB trees without surrogate splits stop rows that are missing a split variable. Our first run barely learned from buildings without a rating. Encoding missing values explicitly took us from 46.8 to 37.6.</a:t>
+              <a:t>Three: the same buildings appear in several years without an id. We reconstructed one, giving 63,907 buildings, so a building's past energy use becomes a feature. It is computed only from earlier years, and a unit test proves it.</a:t>
             </a:r>
           </a:p>
         </p:txBody>
@@ -931,7 +1073,7 @@
           <a:lstStyle/>
           <a:p>
             <a:r>
-              <a:t>(fig. 06, fig. 09) "We validate the way the task works: train on years 1–5, predict year 6, never seen. Same model, a random split would have told us RMSE 37.9; the honest temporal split says 42.5. Then we climbed a ladder of 10 models, each answering one question: - linear regression 46.2, a single tree 40.9: interactions matter; - adding building history brought buildings with a track record down to RMSE 20; - blending raw- and log-scale boosted trees gave our best model: RMSE 37.6, 34% better than the naive baseline, R² 0.57. One MATLAB-specific lesson: MATLAB trees without surrogate splits stop rows that are missing a split variable. Our first run barely learned from buildings without a rating. Encoding missing values explicitly took us from 46.8 to 37.6.</a:t>
+              <a:t>We validate the way the task works: train on years 1 to 5, predict year 6, which the model has never seen. With the same model, a random split would have reported an RMSE of 37.9. The honest temporal split says 42.5.</a:t>
             </a:r>
           </a:p>
         </p:txBody>
@@ -1001,7 +1143,7 @@
           <a:lstStyle/>
           <a:p>
             <a:r>
-              <a:t>(fig. 06, fig. 09) "We validate the way the task works: train on years 1–5, predict year 6, never seen. Same model, a random split would have told us RMSE 37.9; the honest temporal split says 42.5. Then we climbed a ladder of 10 models, each answering one question: - linear regression 46.2, a single tree 40.9: interactions matter; - adding building history brought buildings with a track record down to RMSE 20; - blending raw- and log-scale boosted trees gave our best model: RMSE 37.6, 34% better than the naive baseline, R² 0.57. One MATLAB-specific lesson: MATLAB trees without surrogate splits stop rows that are missing a split variable. Our first run barely learned from buildings without a rating. Encoding missing values explicitly took us from 46.8 to 37.6.</a:t>
+              <a:t>Then we climbed a ladder of 10 models, each answering one question. Linear regression gets 46.2 and a single tree 40.9, so interactions matter. Adding building history brought buildings with a track record down to an RMSE of 20. Blending raw- and log-scale boosted trees gave our best model: RMSE 37.6, 34% better than the naive baseline, with an R² of 0.57.</a:t>
             </a:r>
           </a:p>
         </p:txBody>
@@ -1071,7 +1213,7 @@
           <a:lstStyle/>
           <a:p>
             <a:r>
-              <a:t>(fig. 11, fig. 12) "Partial dependence shows clean responses: a higher ENERGY STAR score means lower energy use, and past use predicts future use. Honest caveat: once the model knows the state, the degree-day features add little, because weather is recorded per state and year. Then we turn predictions into action. A cold-start model predicts what a typical building of the same type, size, age and climate *should* use. Buildings far above that are retrofit candidates: 1,123 buildings, 5% of the stock, using 1.55×10¹⁰ kBtu a year more than expected, 5.3% of all energy used. Ranked by absolute excess energy, so an organisation knows where a retrofit pays off most.</a:t>
+              <a:t>One MATLAB-specific lesson: MATLAB trees without surrogate splits stop rows that are missing the split variable. Our first run barely learned from buildings without a rating. Encoding missing values explicitly took us from 46.8 to 37.6.</a:t>
             </a:r>
           </a:p>
         </p:txBody>
@@ -1141,7 +1283,7 @@
           <a:lstStyle/>
           <a:p>
             <a:r>
-              <a:t>(fig. 11, fig. 12) "Partial dependence shows clean responses: a higher ENERGY STAR score means lower energy use, and past use predicts future use. Honest caveat: once the model knows the state, the degree-day features add little, because weather is recorded per state and year. Then we turn predictions into action. A cold-start model predicts what a typical building of the same type, size, age and climate *should* use. Buildings far above that are retrofit candidates: 1,123 buildings, 5% of the stock, using 1.55×10¹⁰ kBtu a year more than expected, 5.3% of all energy used. Ranked by absolute excess energy, so an organisation knows where a retrofit pays off most.</a:t>
+              <a:t>Partial dependence shows clean responses: a higher ENERGY STAR score means lower energy use, and past use predicts future use. An honest caveat: once the model knows the state, the degree-day features add little, because weather is recorded per state and year.</a:t>
             </a:r>
           </a:p>
         </p:txBody>
@@ -4163,8 +4305,8 @@
         </p:nvSpPr>
         <p:spPr>
           <a:xfrm>
-            <a:off x="731520" y="1828800"/>
-            <a:ext cx="10698480" cy="1280160"/>
+            <a:off x="10789920" y="6400800"/>
+            <a:ext cx="1188720" cy="365760"/>
           </a:xfrm>
           <a:prstGeom prst="rect">
             <a:avLst/>
@@ -4177,19 +4319,19 @@
           </a:bodyPr>
           <a:lstStyle/>
           <a:p>
-            <a:pPr algn="l">
-              <a:spcAft>
-                <a:spcPts val="2700"/>
-              </a:spcAft>
-            </a:pPr>
-            <a:r>
-              <a:rPr sz="5400" b="1">
-                <a:solidFill>
-                  <a:srgbClr val="F2F2F2"/>
-                </a:solidFill>
-                <a:latin typeface="Calibri"/>
-              </a:rPr>
-              <a:t>Which buildings waste energy?</a:t>
+            <a:pPr algn="r">
+              <a:spcAft>
+                <a:spcPts val="550"/>
+              </a:spcAft>
+            </a:pPr>
+            <a:r>
+              <a:rPr sz="1100" b="0">
+                <a:solidFill>
+                  <a:srgbClr val="A8A8A8"/>
+                </a:solidFill>
+                <a:latin typeface="Calibri"/>
+              </a:rPr>
+              <a:t>1 / 12</a:t>
             </a:r>
           </a:p>
         </p:txBody>
@@ -4202,8 +4344,8 @@
         </p:nvSpPr>
         <p:spPr>
           <a:xfrm>
-            <a:off x="731520" y="3017520"/>
-            <a:ext cx="10698480" cy="914400"/>
+            <a:off x="731520" y="1371600"/>
+            <a:ext cx="10698480" cy="1280160"/>
           </a:xfrm>
           <a:prstGeom prst="rect">
             <a:avLst/>
@@ -4218,17 +4360,17 @@
           <a:p>
             <a:pPr algn="l">
               <a:spcAft>
-                <a:spcPts val="1200"/>
-              </a:spcAft>
-            </a:pPr>
-            <a:r>
-              <a:rPr sz="2400" b="0">
-                <a:solidFill>
-                  <a:srgbClr val="A8A8A8"/>
-                </a:solidFill>
-                <a:latin typeface="Calibri"/>
-              </a:rPr>
-              <a:t>Predicting building energy use with MATLAB, and turning predictions into a retrofit shortlist</a:t>
+                <a:spcPts val="2700"/>
+              </a:spcAft>
+            </a:pPr>
+            <a:r>
+              <a:rPr sz="5400" b="1">
+                <a:solidFill>
+                  <a:srgbClr val="F2F2F2"/>
+                </a:solidFill>
+                <a:latin typeface="Calibri"/>
+              </a:rPr>
+              <a:t>Which buildings waste energy?</a:t>
             </a:r>
           </a:p>
         </p:txBody>
@@ -4241,8 +4383,8 @@
         </p:nvSpPr>
         <p:spPr>
           <a:xfrm>
-            <a:off x="731520" y="5120640"/>
-            <a:ext cx="10698480" cy="1097280"/>
+            <a:off x="731520" y="2560320"/>
+            <a:ext cx="10698480" cy="1463040"/>
           </a:xfrm>
           <a:prstGeom prst="rect">
             <a:avLst/>
@@ -4257,6 +4399,84 @@
           <a:p>
             <a:pPr algn="l">
               <a:spcAft>
+                <a:spcPts val="1300"/>
+              </a:spcAft>
+            </a:pPr>
+            <a:r>
+              <a:rPr sz="2600" b="0">
+                <a:solidFill>
+                  <a:srgbClr val="A8A8A8"/>
+                </a:solidFill>
+                <a:latin typeface="Calibri"/>
+              </a:rPr>
+              <a:t>Not which use the most, but which use more than they should, given what they are and where they are.</a:t>
+            </a:r>
+          </a:p>
+        </p:txBody>
+      </p:sp>
+      <p:sp>
+        <p:nvSpPr>
+          <p:cNvPr id="5" name="TextBox 4"/>
+          <p:cNvSpPr txBox="1"/>
+          <p:nvPr/>
+        </p:nvSpPr>
+        <p:spPr>
+          <a:xfrm>
+            <a:off x="731520" y="3931920"/>
+            <a:ext cx="10698480" cy="914400"/>
+          </a:xfrm>
+          <a:prstGeom prst="rect">
+            <a:avLst/>
+          </a:prstGeom>
+          <a:noFill/>
+        </p:spPr>
+        <p:txBody>
+          <a:bodyPr wrap="square">
+            <a:spAutoFit/>
+          </a:bodyPr>
+          <a:lstStyle/>
+          <a:p>
+            <a:pPr algn="l">
+              <a:spcAft>
+                <a:spcPts val="1000"/>
+              </a:spcAft>
+            </a:pPr>
+            <a:r>
+              <a:rPr sz="2000" b="0">
+                <a:solidFill>
+                  <a:srgbClr val="F2F2F2"/>
+                </a:solidFill>
+                <a:latin typeface="Calibri"/>
+              </a:rPr>
+              <a:t>Buildings are among the largest contributors to energy use and carbon emissions.</a:t>
+            </a:r>
+          </a:p>
+        </p:txBody>
+      </p:sp>
+      <p:sp>
+        <p:nvSpPr>
+          <p:cNvPr id="6" name="TextBox 5"/>
+          <p:cNvSpPr txBox="1"/>
+          <p:nvPr/>
+        </p:nvSpPr>
+        <p:spPr>
+          <a:xfrm>
+            <a:off x="731520" y="5212080"/>
+            <a:ext cx="10698480" cy="1097280"/>
+          </a:xfrm>
+          <a:prstGeom prst="rect">
+            <a:avLst/>
+          </a:prstGeom>
+          <a:noFill/>
+        </p:spPr>
+        <p:txBody>
+          <a:bodyPr wrap="square">
+            <a:spAutoFit/>
+          </a:bodyPr>
+          <a:lstStyle/>
+          <a:p>
+            <a:pPr algn="l">
+              <a:spcAft>
                 <a:spcPts val="800"/>
               </a:spcAft>
             </a:pPr>
@@ -4267,7 +4487,7 @@
                 </a:solidFill>
                 <a:latin typeface="Calibri"/>
               </a:rPr>
-              <a:t>NTU Learn to Hack: MATLAB Edition 2026  ·  Predicting Building Energy Consumption</a:t>
+              <a:t>NTU Learn to Hack: MATLAB Edition 2026  ·  Predicting Building Energy Consumption  ·  built in MATLAB</a:t>
             </a:r>
           </a:p>
           <a:p>
@@ -4322,8 +4542,8 @@
         </p:nvSpPr>
         <p:spPr>
           <a:xfrm>
-            <a:off x="548640" y="320040"/>
-            <a:ext cx="10972800" cy="365760"/>
+            <a:off x="10789920" y="6400800"/>
+            <a:ext cx="1188720" cy="365760"/>
           </a:xfrm>
           <a:prstGeom prst="rect">
             <a:avLst/>
@@ -4336,19 +4556,19 @@
           </a:bodyPr>
           <a:lstStyle/>
           <a:p>
-            <a:pPr algn="l">
-              <a:spcAft>
-                <a:spcPts val="650"/>
-              </a:spcAft>
-            </a:pPr>
-            <a:r>
-              <a:rPr sz="1300" b="1">
-                <a:solidFill>
-                  <a:srgbClr val="E07B39"/>
-                </a:solidFill>
-                <a:latin typeface="Calibri"/>
-              </a:rPr>
-              <a:t>ENGINEERING QUALITY</a:t>
+            <a:pPr algn="r">
+              <a:spcAft>
+                <a:spcPts val="550"/>
+              </a:spcAft>
+            </a:pPr>
+            <a:r>
+              <a:rPr sz="1100" b="0">
+                <a:solidFill>
+                  <a:srgbClr val="A8A8A8"/>
+                </a:solidFill>
+                <a:latin typeface="Calibri"/>
+              </a:rPr>
+              <a:t>10 / 12</a:t>
             </a:r>
           </a:p>
         </p:txBody>
@@ -4361,8 +4581,8 @@
         </p:nvSpPr>
         <p:spPr>
           <a:xfrm>
-            <a:off x="548640" y="640080"/>
-            <a:ext cx="11155680" cy="822960"/>
+            <a:off x="548640" y="320040"/>
+            <a:ext cx="10972800" cy="365760"/>
           </a:xfrm>
           <a:prstGeom prst="rect">
             <a:avLst/>
@@ -4377,17 +4597,17 @@
           <a:p>
             <a:pPr algn="l">
               <a:spcAft>
-                <a:spcPts val="1600"/>
-              </a:spcAft>
-            </a:pPr>
-            <a:r>
-              <a:rPr sz="3200" b="1">
-                <a:solidFill>
-                  <a:srgbClr val="F2F2F2"/>
-                </a:solidFill>
-                <a:latin typeface="Calibri"/>
-              </a:rPr>
-              <a:t>One command, reproducible, tested</a:t>
+                <a:spcPts val="650"/>
+              </a:spcAft>
+            </a:pPr>
+            <a:r>
+              <a:rPr sz="1300" b="1">
+                <a:solidFill>
+                  <a:srgbClr val="E07B39"/>
+                </a:solidFill>
+                <a:latin typeface="Calibri"/>
+              </a:rPr>
+              <a:t>IMPACT</a:t>
             </a:r>
           </a:p>
         </p:txBody>
@@ -4400,8 +4620,8 @@
         </p:nvSpPr>
         <p:spPr>
           <a:xfrm>
-            <a:off x="731520" y="1737360"/>
-            <a:ext cx="5669280" cy="4572000"/>
+            <a:off x="548640" y="640080"/>
+            <a:ext cx="11155680" cy="822960"/>
           </a:xfrm>
           <a:prstGeom prst="rect">
             <a:avLst/>
@@ -4416,81 +4636,17 @@
           <a:p>
             <a:pPr algn="l">
               <a:spcAft>
-                <a:spcPts val="1500"/>
-              </a:spcAft>
-            </a:pPr>
-            <a:r>
-              <a:rPr sz="3000" b="1">
-                <a:solidFill>
-                  <a:srgbClr val="E07B39"/>
-                </a:solidFill>
-                <a:latin typeface="Calibri"/>
-              </a:rPr>
-              <a:t>&gt;&gt; main</a:t>
-            </a:r>
-          </a:p>
-          <a:p>
-            <a:pPr algn="l">
-              <a:spcAft>
-                <a:spcPts val="950"/>
-              </a:spcAft>
-            </a:pPr>
-            <a:r>
-              <a:rPr sz="1900" b="0">
+                <a:spcPts val="1600"/>
+              </a:spcAft>
+            </a:pPr>
+            <a:r>
+              <a:rPr sz="3200" b="1">
                 <a:solidFill>
                   <a:srgbClr val="F2F2F2"/>
                 </a:solidFill>
                 <a:latin typeface="Calibri"/>
               </a:rPr>
-              <a:t>Raw CSV → cleaning → features → 10-model ladder → validated submission + 12 figures</a:t>
-            </a:r>
-          </a:p>
-          <a:p>
-            <a:pPr algn="l">
-              <a:spcAft>
-                <a:spcPts val="950"/>
-              </a:spcAft>
-            </a:pPr>
-            <a:r>
-              <a:rPr sz="1900" b="0">
-                <a:solidFill>
-                  <a:srgbClr val="F2F2F2"/>
-                </a:solidFill>
-                <a:latin typeface="Calibri"/>
-              </a:rPr>
-              <a:t>Modular functions in src/ with argument validation</a:t>
-            </a:r>
-          </a:p>
-          <a:p>
-            <a:pPr algn="l">
-              <a:spcAft>
-                <a:spcPts val="950"/>
-              </a:spcAft>
-            </a:pPr>
-            <a:r>
-              <a:rPr sz="1900" b="0">
-                <a:solidFill>
-                  <a:srgbClr val="F2F2F2"/>
-                </a:solidFill>
-                <a:latin typeface="Calibri"/>
-              </a:rPr>
-              <a:t>matlab.unittest tests, including proof that history features are causal</a:t>
-            </a:r>
-          </a:p>
-          <a:p>
-            <a:pPr algn="l">
-              <a:spcAft>
-                <a:spcPts val="950"/>
-              </a:spcAft>
-            </a:pPr>
-            <a:r>
-              <a:rPr sz="1900" b="0">
-                <a:solidFill>
-                  <a:srgbClr val="F2F2F2"/>
-                </a:solidFill>
-                <a:latin typeface="Calibri"/>
-              </a:rPr>
-              <a:t>Every number in the README is printed by MATLAB</a:t>
+              <a:t>From prediction to action: the retrofit shortlist</a:t>
             </a:r>
           </a:p>
         </p:txBody>
@@ -4503,8 +4659,8 @@
         </p:nvSpPr>
         <p:spPr>
           <a:xfrm>
-            <a:off x="6766560" y="1737360"/>
-            <a:ext cx="4937760" cy="4572000"/>
+            <a:off x="548640" y="1737360"/>
+            <a:ext cx="4389120" cy="4846320"/>
           </a:xfrm>
           <a:prstGeom prst="rect">
             <a:avLst/>
@@ -4519,91 +4675,614 @@
           <a:p>
             <a:pPr algn="l">
               <a:spcAft>
-                <a:spcPts val="1100"/>
-              </a:spcAft>
-            </a:pPr>
-            <a:r>
-              <a:rPr sz="2200" b="1">
+                <a:spcPts val="900"/>
+              </a:spcAft>
+            </a:pPr>
+            <a:r>
+              <a:rPr sz="1800" b="0">
+                <a:solidFill>
+                  <a:srgbClr val="F2F2F2"/>
+                </a:solidFill>
+                <a:latin typeface="Calibri"/>
+              </a:rPr>
+              <a:t>Cold-start model = what a typical building of the same type, size, age and climate should use</a:t>
+            </a:r>
+          </a:p>
+          <a:p>
+            <a:pPr algn="l">
+              <a:spcAft>
+                <a:spcPts val="1500"/>
+              </a:spcAft>
+            </a:pPr>
+            <a:r>
+              <a:rPr sz="3000" b="1">
                 <a:solidFill>
                   <a:srgbClr val="E07B39"/>
                 </a:solidFill>
                 <a:latin typeface="Calibri"/>
               </a:rPr>
-              <a:t>Next steps</a:t>
+              <a:t>1,123 buildings</a:t>
             </a:r>
           </a:p>
           <a:p>
             <a:pPr algn="l">
               <a:spcAft>
-                <a:spcPts val="950"/>
-              </a:spcAft>
-            </a:pPr>
-            <a:r>
-              <a:rPr sz="1900" b="0">
+                <a:spcPts val="900"/>
+              </a:spcAft>
+            </a:pPr>
+            <a:r>
+              <a:rPr sz="1800" b="0">
                 <a:solidFill>
                   <a:srgbClr val="F2F2F2"/>
                 </a:solidFill>
                 <a:latin typeface="Calibri"/>
               </a:rPr>
-              <a:t>Monthly meter data and occupancy</a:t>
+              <a:t>5% of the stock</a:t>
             </a:r>
           </a:p>
           <a:p>
             <a:pPr algn="l">
               <a:spcAft>
-                <a:spcPts val="950"/>
-              </a:spcAft>
-            </a:pPr>
-            <a:r>
-              <a:rPr sz="1900" b="0">
+                <a:spcPts val="1000"/>
+              </a:spcAft>
+            </a:pPr>
+            <a:r>
+              <a:rPr sz="2000" b="1">
                 <a:solidFill>
                   <a:srgbClr val="F2F2F2"/>
                 </a:solidFill>
                 <a:latin typeface="Calibri"/>
               </a:rPr>
-              <a:t>Optimise which retrofits to fund under a budget</a:t>
+              <a:t>1.55 × 10¹⁰ kBtu/yr above expected</a:t>
             </a:r>
           </a:p>
           <a:p>
             <a:pPr algn="l">
               <a:spcAft>
-                <a:spcPts val="950"/>
-              </a:spcAft>
-            </a:pPr>
-            <a:r>
-              <a:rPr sz="1900" b="0">
+                <a:spcPts val="900"/>
+              </a:spcAft>
+            </a:pPr>
+            <a:r>
+              <a:rPr sz="1800" b="0">
+                <a:solidFill>
+                  <a:srgbClr val="A8A8A8"/>
+                </a:solidFill>
+                <a:latin typeface="Calibri"/>
+              </a:rPr>
+              <a:t>= 5.3% of all energy used</a:t>
+            </a:r>
+          </a:p>
+          <a:p>
+            <a:pPr algn="l">
+              <a:spcAft>
+                <a:spcPts val="850"/>
+              </a:spcAft>
+            </a:pPr>
+            <a:r>
+              <a:rPr sz="1700" b="0">
                 <a:solidFill>
                   <a:srgbClr val="F2F2F2"/>
                 </a:solidFill>
                 <a:latin typeface="Calibri"/>
               </a:rPr>
-              <a:t>Per-building uncertainty</a:t>
-            </a:r>
-          </a:p>
+              <a:t>Ranked by absolute excess energy</a:t>
+            </a:r>
+          </a:p>
+        </p:txBody>
+      </p:sp>
+      <p:pic>
+        <p:nvPicPr>
+          <p:cNvPr id="6" name="Picture 5" descr="12_retrofit_shortlist.png"/>
+          <p:cNvPicPr>
+            <a:picLocks noChangeAspect="1"/>
+          </p:cNvPicPr>
+          <p:nvPr/>
+        </p:nvPicPr>
+        <p:blipFill>
+          <a:blip r:embed="rId3"/>
+          <a:stretch>
+            <a:fillRect/>
+          </a:stretch>
+        </p:blipFill>
+        <p:spPr>
+          <a:xfrm>
+            <a:off x="5029200" y="2077449"/>
+            <a:ext cx="6858000" cy="3983262"/>
+          </a:xfrm>
+          <a:prstGeom prst="rect">
+            <a:avLst/>
+          </a:prstGeom>
+        </p:spPr>
+      </p:pic>
+    </p:spTree>
+  </p:cSld>
+  <p:clrMapOvr>
+    <a:masterClrMapping/>
+  </p:clrMapOvr>
+</p:sld>
+</file>
+
+<file path=ppt/slides/slide11.xml><?xml version="1.0" encoding="utf-8"?>
+<p:sld xmlns:a="http://schemas.openxmlformats.org/drawingml/2006/main" xmlns:p="http://schemas.openxmlformats.org/presentationml/2006/main" xmlns:r="http://schemas.openxmlformats.org/officeDocument/2006/relationships">
+  <p:cSld>
+    <p:bg>
+      <p:bgPr>
+        <a:solidFill>
+          <a:srgbClr val="121212"/>
+        </a:solidFill>
+        <a:effectLst/>
+      </p:bgPr>
+    </p:bg>
+    <p:spTree>
+      <p:nvGrpSpPr>
+        <p:cNvPr id="1" name=""/>
+        <p:cNvGrpSpPr/>
+        <p:nvPr/>
+      </p:nvGrpSpPr>
+      <p:grpSpPr/>
+      <p:sp>
+        <p:nvSpPr>
+          <p:cNvPr id="2" name="TextBox 1"/>
+          <p:cNvSpPr txBox="1"/>
+          <p:nvPr/>
+        </p:nvSpPr>
+        <p:spPr>
+          <a:xfrm>
+            <a:off x="10789920" y="6400800"/>
+            <a:ext cx="1188720" cy="365760"/>
+          </a:xfrm>
+          <a:prstGeom prst="rect">
+            <a:avLst/>
+          </a:prstGeom>
+          <a:noFill/>
+        </p:spPr>
+        <p:txBody>
+          <a:bodyPr wrap="square">
+            <a:spAutoFit/>
+          </a:bodyPr>
+          <a:lstStyle/>
+          <a:p>
+            <a:pPr algn="r">
+              <a:spcAft>
+                <a:spcPts val="550"/>
+              </a:spcAft>
+            </a:pPr>
+            <a:r>
+              <a:rPr sz="1100" b="0">
+                <a:solidFill>
+                  <a:srgbClr val="A8A8A8"/>
+                </a:solidFill>
+                <a:latin typeface="Calibri"/>
+              </a:rPr>
+              <a:t>11 / 12</a:t>
+            </a:r>
+          </a:p>
+        </p:txBody>
+      </p:sp>
+      <p:sp>
+        <p:nvSpPr>
+          <p:cNvPr id="3" name="TextBox 2"/>
+          <p:cNvSpPr txBox="1"/>
+          <p:nvPr/>
+        </p:nvSpPr>
+        <p:spPr>
+          <a:xfrm>
+            <a:off x="548640" y="320040"/>
+            <a:ext cx="10972800" cy="365760"/>
+          </a:xfrm>
+          <a:prstGeom prst="rect">
+            <a:avLst/>
+          </a:prstGeom>
+          <a:noFill/>
+        </p:spPr>
+        <p:txBody>
+          <a:bodyPr wrap="square">
+            <a:spAutoFit/>
+          </a:bodyPr>
+          <a:lstStyle/>
           <a:p>
             <a:pPr algn="l">
               <a:spcAft>
-                <a:spcPts val="1500"/>
-              </a:spcAft>
-            </a:pPr>
-            <a:r>
-              <a:rPr sz="3000" b="1">
+                <a:spcPts val="650"/>
+              </a:spcAft>
+            </a:pPr>
+            <a:r>
+              <a:rPr sz="1300" b="1">
+                <a:solidFill>
+                  <a:srgbClr val="E07B39"/>
+                </a:solidFill>
+                <a:latin typeface="Calibri"/>
+              </a:rPr>
+              <a:t>ENGINEERING QUALITY</a:t>
+            </a:r>
+          </a:p>
+        </p:txBody>
+      </p:sp>
+      <p:sp>
+        <p:nvSpPr>
+          <p:cNvPr id="4" name="TextBox 3"/>
+          <p:cNvSpPr txBox="1"/>
+          <p:nvPr/>
+        </p:nvSpPr>
+        <p:spPr>
+          <a:xfrm>
+            <a:off x="548640" y="640080"/>
+            <a:ext cx="11155680" cy="822960"/>
+          </a:xfrm>
+          <a:prstGeom prst="rect">
+            <a:avLst/>
+          </a:prstGeom>
+          <a:noFill/>
+        </p:spPr>
+        <p:txBody>
+          <a:bodyPr wrap="square">
+            <a:spAutoFit/>
+          </a:bodyPr>
+          <a:lstStyle/>
+          <a:p>
+            <a:pPr algn="l">
+              <a:spcAft>
+                <a:spcPts val="1600"/>
+              </a:spcAft>
+            </a:pPr>
+            <a:r>
+              <a:rPr sz="3200" b="1">
                 <a:solidFill>
                   <a:srgbClr val="F2F2F2"/>
                 </a:solidFill>
                 <a:latin typeface="Calibri"/>
               </a:rPr>
+              <a:t>One command, reproducible, tested</a:t>
+            </a:r>
+          </a:p>
+        </p:txBody>
+      </p:sp>
+      <p:sp>
+        <p:nvSpPr>
+          <p:cNvPr id="5" name="TextBox 4"/>
+          <p:cNvSpPr txBox="1"/>
+          <p:nvPr/>
+        </p:nvSpPr>
+        <p:spPr>
+          <a:xfrm>
+            <a:off x="731520" y="1737360"/>
+            <a:ext cx="10515600" cy="4572000"/>
+          </a:xfrm>
+          <a:prstGeom prst="rect">
+            <a:avLst/>
+          </a:prstGeom>
+          <a:noFill/>
+        </p:spPr>
+        <p:txBody>
+          <a:bodyPr wrap="square">
+            <a:spAutoFit/>
+          </a:bodyPr>
+          <a:lstStyle/>
+          <a:p>
+            <a:pPr algn="l">
+              <a:spcAft>
+                <a:spcPts val="2000"/>
+              </a:spcAft>
+            </a:pPr>
+            <a:r>
+              <a:rPr sz="4000" b="1">
+                <a:solidFill>
+                  <a:srgbClr val="E07B39"/>
+                </a:solidFill>
+                <a:latin typeface="Calibri"/>
+              </a:rPr>
+              <a:t>&gt;&gt; main</a:t>
+            </a:r>
+          </a:p>
+          <a:p>
+            <a:pPr algn="l">
+              <a:spcAft>
+                <a:spcPts val="1200"/>
+              </a:spcAft>
+            </a:pPr>
+            <a:r>
+              <a:rPr sz="2400" b="0">
+                <a:solidFill>
+                  <a:srgbClr val="F2F2F2"/>
+                </a:solidFill>
+                <a:latin typeface="Calibri"/>
+              </a:rPr>
+              <a:t>Raw CSV → submission and figures, in one command</a:t>
+            </a:r>
+          </a:p>
+          <a:p>
+            <a:pPr algn="l">
+              <a:spcAft>
+                <a:spcPts val="1200"/>
+              </a:spcAft>
+            </a:pPr>
+            <a:r>
+              <a:rPr sz="2400" b="0">
+                <a:solidFill>
+                  <a:srgbClr val="F2F2F2"/>
+                </a:solidFill>
+                <a:latin typeface="Calibri"/>
+              </a:rPr>
+              <a:t>Modular functions with argument validation</a:t>
+            </a:r>
+          </a:p>
+          <a:p>
+            <a:pPr algn="l">
+              <a:spcAft>
+                <a:spcPts val="1200"/>
+              </a:spcAft>
+            </a:pPr>
+            <a:r>
+              <a:rPr sz="2400" b="0">
+                <a:solidFill>
+                  <a:srgbClr val="F2F2F2"/>
+                </a:solidFill>
+                <a:latin typeface="Calibri"/>
+              </a:rPr>
+              <a:t>Unit tests in matlab.unittest · validated submission file</a:t>
+            </a:r>
+          </a:p>
+          <a:p>
+            <a:pPr algn="l">
+              <a:spcAft>
+                <a:spcPts val="1200"/>
+              </a:spcAft>
+            </a:pPr>
+            <a:r>
+              <a:rPr sz="2400" b="0">
+                <a:solidFill>
+                  <a:srgbClr val="F2F2F2"/>
+                </a:solidFill>
+                <a:latin typeface="Calibri"/>
+              </a:rPr>
+              <a:t>Every number in our README was printed by MATLAB</a:t>
+            </a:r>
+          </a:p>
+        </p:txBody>
+      </p:sp>
+    </p:spTree>
+  </p:cSld>
+  <p:clrMapOvr>
+    <a:masterClrMapping/>
+  </p:clrMapOvr>
+</p:sld>
+</file>
+
+<file path=ppt/slides/slide12.xml><?xml version="1.0" encoding="utf-8"?>
+<p:sld xmlns:a="http://schemas.openxmlformats.org/drawingml/2006/main" xmlns:p="http://schemas.openxmlformats.org/presentationml/2006/main" xmlns:r="http://schemas.openxmlformats.org/officeDocument/2006/relationships">
+  <p:cSld>
+    <p:bg>
+      <p:bgPr>
+        <a:solidFill>
+          <a:srgbClr val="121212"/>
+        </a:solidFill>
+        <a:effectLst/>
+      </p:bgPr>
+    </p:bg>
+    <p:spTree>
+      <p:nvGrpSpPr>
+        <p:cNvPr id="1" name=""/>
+        <p:cNvGrpSpPr/>
+        <p:nvPr/>
+      </p:nvGrpSpPr>
+      <p:grpSpPr/>
+      <p:sp>
+        <p:nvSpPr>
+          <p:cNvPr id="2" name="TextBox 1"/>
+          <p:cNvSpPr txBox="1"/>
+          <p:nvPr/>
+        </p:nvSpPr>
+        <p:spPr>
+          <a:xfrm>
+            <a:off x="10789920" y="6400800"/>
+            <a:ext cx="1188720" cy="365760"/>
+          </a:xfrm>
+          <a:prstGeom prst="rect">
+            <a:avLst/>
+          </a:prstGeom>
+          <a:noFill/>
+        </p:spPr>
+        <p:txBody>
+          <a:bodyPr wrap="square">
+            <a:spAutoFit/>
+          </a:bodyPr>
+          <a:lstStyle/>
+          <a:p>
+            <a:pPr algn="r">
+              <a:spcAft>
+                <a:spcPts val="550"/>
+              </a:spcAft>
+            </a:pPr>
+            <a:r>
+              <a:rPr sz="1100" b="0">
+                <a:solidFill>
+                  <a:srgbClr val="A8A8A8"/>
+                </a:solidFill>
+                <a:latin typeface="Calibri"/>
+              </a:rPr>
+              <a:t>12 / 12</a:t>
+            </a:r>
+          </a:p>
+        </p:txBody>
+      </p:sp>
+      <p:sp>
+        <p:nvSpPr>
+          <p:cNvPr id="3" name="TextBox 2"/>
+          <p:cNvSpPr txBox="1"/>
+          <p:nvPr/>
+        </p:nvSpPr>
+        <p:spPr>
+          <a:xfrm>
+            <a:off x="731520" y="1280160"/>
+            <a:ext cx="10698480" cy="548640"/>
+          </a:xfrm>
+          <a:prstGeom prst="rect">
+            <a:avLst/>
+          </a:prstGeom>
+          <a:noFill/>
+        </p:spPr>
+        <p:txBody>
+          <a:bodyPr wrap="square">
+            <a:spAutoFit/>
+          </a:bodyPr>
+          <a:lstStyle/>
+          <a:p>
+            <a:pPr algn="l">
+              <a:spcAft>
+                <a:spcPts val="800"/>
+              </a:spcAft>
+            </a:pPr>
+            <a:r>
+              <a:rPr sz="1600" b="1">
+                <a:solidFill>
+                  <a:srgbClr val="E07B39"/>
+                </a:solidFill>
+                <a:latin typeface="Calibri"/>
+              </a:rPr>
+              <a:t>NEXT STEPS</a:t>
+            </a:r>
+          </a:p>
+        </p:txBody>
+      </p:sp>
+      <p:sp>
+        <p:nvSpPr>
+          <p:cNvPr id="4" name="TextBox 3"/>
+          <p:cNvSpPr txBox="1"/>
+          <p:nvPr/>
+        </p:nvSpPr>
+        <p:spPr>
+          <a:xfrm>
+            <a:off x="731520" y="1828800"/>
+            <a:ext cx="10698480" cy="2286000"/>
+          </a:xfrm>
+          <a:prstGeom prst="rect">
+            <a:avLst/>
+          </a:prstGeom>
+          <a:noFill/>
+        </p:spPr>
+        <p:txBody>
+          <a:bodyPr wrap="square">
+            <a:spAutoFit/>
+          </a:bodyPr>
+          <a:lstStyle/>
+          <a:p>
+            <a:pPr algn="l">
+              <a:spcAft>
+                <a:spcPts val="1400"/>
+              </a:spcAft>
+            </a:pPr>
+            <a:r>
+              <a:rPr sz="2800" b="0">
+                <a:solidFill>
+                  <a:srgbClr val="F2F2F2"/>
+                </a:solidFill>
+                <a:latin typeface="Calibri"/>
+              </a:rPr>
+              <a:t>Monthly meter data</a:t>
+            </a:r>
+          </a:p>
+          <a:p>
+            <a:pPr algn="l">
+              <a:spcAft>
+                <a:spcPts val="1400"/>
+              </a:spcAft>
+            </a:pPr>
+            <a:r>
+              <a:rPr sz="2800" b="0">
+                <a:solidFill>
+                  <a:srgbClr val="F2F2F2"/>
+                </a:solidFill>
+                <a:latin typeface="Calibri"/>
+              </a:rPr>
+              <a:t>Occupancy</a:t>
+            </a:r>
+          </a:p>
+          <a:p>
+            <a:pPr algn="l">
+              <a:spcAft>
+                <a:spcPts val="1400"/>
+              </a:spcAft>
+            </a:pPr>
+            <a:r>
+              <a:rPr sz="2800" b="0">
+                <a:solidFill>
+                  <a:srgbClr val="F2F2F2"/>
+                </a:solidFill>
+                <a:latin typeface="Calibri"/>
+              </a:rPr>
+              <a:t>Optimising which retrofits to fund first</a:t>
+            </a:r>
+          </a:p>
+        </p:txBody>
+      </p:sp>
+      <p:sp>
+        <p:nvSpPr>
+          <p:cNvPr id="5" name="TextBox 4"/>
+          <p:cNvSpPr txBox="1"/>
+          <p:nvPr/>
+        </p:nvSpPr>
+        <p:spPr>
+          <a:xfrm>
+            <a:off x="731520" y="4389120"/>
+            <a:ext cx="10698480" cy="1097280"/>
+          </a:xfrm>
+          <a:prstGeom prst="rect">
+            <a:avLst/>
+          </a:prstGeom>
+          <a:noFill/>
+        </p:spPr>
+        <p:txBody>
+          <a:bodyPr wrap="square">
+            <a:spAutoFit/>
+          </a:bodyPr>
+          <a:lstStyle/>
+          <a:p>
+            <a:pPr algn="l">
+              <a:spcAft>
+                <a:spcPts val="2700"/>
+              </a:spcAft>
+            </a:pPr>
+            <a:r>
+              <a:rPr sz="5400" b="1">
+                <a:solidFill>
+                  <a:srgbClr val="F2F2F2"/>
+                </a:solidFill>
+                <a:latin typeface="Calibri"/>
+              </a:rPr>
               <a:t>Thank you</a:t>
             </a:r>
           </a:p>
+        </p:txBody>
+      </p:sp>
+      <p:sp>
+        <p:nvSpPr>
+          <p:cNvPr id="6" name="TextBox 5"/>
+          <p:cNvSpPr txBox="1"/>
+          <p:nvPr/>
+        </p:nvSpPr>
+        <p:spPr>
+          <a:xfrm>
+            <a:off x="731520" y="5486400"/>
+            <a:ext cx="10698480" cy="548640"/>
+          </a:xfrm>
+          <a:prstGeom prst="rect">
+            <a:avLst/>
+          </a:prstGeom>
+          <a:noFill/>
+        </p:spPr>
+        <p:txBody>
+          <a:bodyPr wrap="square">
+            <a:spAutoFit/>
+          </a:bodyPr>
+          <a:lstStyle/>
           <a:p>
             <a:pPr algn="l">
               <a:spcAft>
-                <a:spcPts val="750"/>
-              </a:spcAft>
-            </a:pPr>
-            <a:r>
-              <a:rPr sz="1500" b="0">
+                <a:spcPts val="900"/>
+              </a:spcAft>
+            </a:pPr>
+            <a:r>
+              <a:rPr sz="1800" b="0">
                 <a:solidFill>
                   <a:srgbClr val="A8A8A8"/>
                 </a:solidFill>
@@ -4648,8 +5327,8 @@
         </p:nvSpPr>
         <p:spPr>
           <a:xfrm>
-            <a:off x="548640" y="320040"/>
-            <a:ext cx="10972800" cy="365760"/>
+            <a:off x="10789920" y="6400800"/>
+            <a:ext cx="1188720" cy="365760"/>
           </a:xfrm>
           <a:prstGeom prst="rect">
             <a:avLst/>
@@ -4662,19 +5341,19 @@
           </a:bodyPr>
           <a:lstStyle/>
           <a:p>
-            <a:pPr algn="l">
-              <a:spcAft>
-                <a:spcPts val="650"/>
-              </a:spcAft>
-            </a:pPr>
-            <a:r>
-              <a:rPr sz="1300" b="1">
-                <a:solidFill>
-                  <a:srgbClr val="E07B39"/>
-                </a:solidFill>
-                <a:latin typeface="Calibri"/>
-              </a:rPr>
-              <a:t>THE PROBLEM</a:t>
+            <a:pPr algn="r">
+              <a:spcAft>
+                <a:spcPts val="550"/>
+              </a:spcAft>
+            </a:pPr>
+            <a:r>
+              <a:rPr sz="1100" b="0">
+                <a:solidFill>
+                  <a:srgbClr val="A8A8A8"/>
+                </a:solidFill>
+                <a:latin typeface="Calibri"/>
+              </a:rPr>
+              <a:t>2 / 12</a:t>
             </a:r>
           </a:p>
         </p:txBody>
@@ -4687,8 +5366,8 @@
         </p:nvSpPr>
         <p:spPr>
           <a:xfrm>
-            <a:off x="548640" y="640080"/>
-            <a:ext cx="11155680" cy="822960"/>
+            <a:off x="548640" y="320040"/>
+            <a:ext cx="10972800" cy="365760"/>
           </a:xfrm>
           <a:prstGeom prst="rect">
             <a:avLst/>
@@ -4703,17 +5382,17 @@
           <a:p>
             <a:pPr algn="l">
               <a:spcAft>
-                <a:spcPts val="1600"/>
-              </a:spcAft>
-            </a:pPr>
-            <a:r>
-              <a:rPr sz="3200" b="1">
-                <a:solidFill>
-                  <a:srgbClr val="F2F2F2"/>
-                </a:solidFill>
-                <a:latin typeface="Calibri"/>
-              </a:rPr>
-              <a:t>Not which buildings use the most, but which use more than they should</a:t>
+                <a:spcPts val="650"/>
+              </a:spcAft>
+            </a:pPr>
+            <a:r>
+              <a:rPr sz="1300" b="1">
+                <a:solidFill>
+                  <a:srgbClr val="E07B39"/>
+                </a:solidFill>
+                <a:latin typeface="Calibri"/>
+              </a:rPr>
+              <a:t>PHYSICS FRAMING</a:t>
             </a:r>
           </a:p>
         </p:txBody>
@@ -4726,8 +5405,8 @@
         </p:nvSpPr>
         <p:spPr>
           <a:xfrm>
-            <a:off x="731520" y="2103120"/>
-            <a:ext cx="10515600" cy="4114800"/>
+            <a:off x="548640" y="640080"/>
+            <a:ext cx="11155680" cy="822960"/>
           </a:xfrm>
           <a:prstGeom prst="rect">
             <a:avLst/>
@@ -4742,53 +5421,132 @@
           <a:p>
             <a:pPr algn="l">
               <a:spcAft>
-                <a:spcPts val="1300"/>
-              </a:spcAft>
-            </a:pPr>
-            <a:r>
-              <a:rPr sz="2600" b="0">
+                <a:spcPts val="1600"/>
+              </a:spcAft>
+            </a:pPr>
+            <a:r>
+              <a:rPr sz="3200" b="1">
                 <a:solidFill>
                   <a:srgbClr val="F2F2F2"/>
                 </a:solidFill>
                 <a:latin typeface="Calibri"/>
               </a:rPr>
-              <a:t>Buildings are major contributors to global energy use and carbon emissions.</a:t>
-            </a:r>
-          </a:p>
+              <a:t>Energy balance: Q ≈ UA · ΔT summed over the year</a:t>
+            </a:r>
+          </a:p>
+        </p:txBody>
+      </p:sp>
+      <p:sp>
+        <p:nvSpPr>
+          <p:cNvPr id="5" name="TextBox 4"/>
+          <p:cNvSpPr txBox="1"/>
+          <p:nvPr/>
+        </p:nvSpPr>
+        <p:spPr>
+          <a:xfrm>
+            <a:off x="548640" y="1828800"/>
+            <a:ext cx="4206240" cy="4389120"/>
+          </a:xfrm>
+          <a:prstGeom prst="rect">
+            <a:avLst/>
+          </a:prstGeom>
+          <a:noFill/>
+        </p:spPr>
+        <p:txBody>
+          <a:bodyPr wrap="square">
+            <a:spAutoFit/>
+          </a:bodyPr>
+          <a:lstStyle/>
           <a:p>
             <a:pPr algn="l">
               <a:spcAft>
-                <a:spcPts val="1300"/>
-              </a:spcAft>
-            </a:pPr>
-            <a:r>
-              <a:rPr sz="2600" b="0">
+                <a:spcPts val="1000"/>
+              </a:spcAft>
+            </a:pPr>
+            <a:r>
+              <a:rPr sz="2000" b="0">
                 <a:solidFill>
                   <a:srgbClr val="F2F2F2"/>
                 </a:solidFill>
                 <a:latin typeface="Calibri"/>
               </a:rPr>
-              <a:t>Retrofits pay off most where a building uses far more than its type, size, age and climate explain.</a:t>
+              <a:t>Heating demand scales with heating degree days.</a:t>
             </a:r>
           </a:p>
           <a:p>
             <a:pPr algn="l">
               <a:spcAft>
-                <a:spcPts val="1300"/>
-              </a:spcAft>
-            </a:pPr>
-            <a:r>
-              <a:rPr sz="2600" b="0">
+                <a:spcPts val="900"/>
+              </a:spcAft>
+            </a:pPr>
+            <a:r>
+              <a:rPr sz="1800" b="1">
+                <a:solidFill>
+                  <a:srgbClr val="E07B39"/>
+                </a:solidFill>
+                <a:latin typeface="Calibri"/>
+              </a:rPr>
+              <a:t>Features we engineered:</a:t>
+            </a:r>
+          </a:p>
+          <a:p>
+            <a:pPr algn="l">
+              <a:spcAft>
+                <a:spcPts val="900"/>
+              </a:spcAft>
+            </a:pPr>
+            <a:r>
+              <a:rPr sz="1800" b="0">
                 <a:solidFill>
                   <a:srgbClr val="F2F2F2"/>
                 </a:solidFill>
                 <a:latin typeface="Calibri"/>
               </a:rPr>
-              <a:t>We predict annual site Energy Use Intensity (kBtu/ft²/yr) for 75,757 building-years (WiDS 2022), entirely in MATLAB.</a:t>
-            </a:r>
-          </a:p>
-        </p:txBody>
-      </p:sp>
+              <a:t>degree days · seasonal mean temperatures · annual temperature range · log floor area · building age</a:t>
+            </a:r>
+          </a:p>
+          <a:p>
+            <a:pPr algn="l">
+              <a:spcAft>
+                <a:spcPts val="950"/>
+              </a:spcAft>
+            </a:pPr>
+            <a:r>
+              <a:rPr sz="1900" b="1">
+                <a:solidFill>
+                  <a:srgbClr val="F2F2F2"/>
+                </a:solidFill>
+                <a:latin typeface="Calibri"/>
+              </a:rPr>
+              <a:t>Median EUI: ≈ 36–53 in milder climates vs ≈ 68–82 in colder ones (kBtu/ft²/yr)</a:t>
+            </a:r>
+          </a:p>
+        </p:txBody>
+      </p:sp>
+      <p:pic>
+        <p:nvPicPr>
+          <p:cNvPr id="6" name="Picture 5" descr="05_eui_vs_hdd.png"/>
+          <p:cNvPicPr>
+            <a:picLocks noChangeAspect="1"/>
+          </p:cNvPicPr>
+          <p:nvPr/>
+        </p:nvPicPr>
+        <p:blipFill>
+          <a:blip r:embed="rId3"/>
+          <a:stretch>
+            <a:fillRect/>
+          </a:stretch>
+        </p:blipFill>
+        <p:spPr>
+          <a:xfrm>
+            <a:off x="4937760" y="1688253"/>
+            <a:ext cx="6766560" cy="4761653"/>
+          </a:xfrm>
+          <a:prstGeom prst="rect">
+            <a:avLst/>
+          </a:prstGeom>
+        </p:spPr>
+      </p:pic>
     </p:spTree>
   </p:cSld>
   <p:clrMapOvr>
@@ -4823,8 +5581,8 @@
         </p:nvSpPr>
         <p:spPr>
           <a:xfrm>
-            <a:off x="548640" y="320040"/>
-            <a:ext cx="10972800" cy="365760"/>
+            <a:off x="10789920" y="6400800"/>
+            <a:ext cx="1188720" cy="365760"/>
           </a:xfrm>
           <a:prstGeom prst="rect">
             <a:avLst/>
@@ -4837,19 +5595,19 @@
           </a:bodyPr>
           <a:lstStyle/>
           <a:p>
-            <a:pPr algn="l">
-              <a:spcAft>
-                <a:spcPts val="650"/>
-              </a:spcAft>
-            </a:pPr>
-            <a:r>
-              <a:rPr sz="1300" b="1">
-                <a:solidFill>
-                  <a:srgbClr val="E07B39"/>
-                </a:solidFill>
-                <a:latin typeface="Calibri"/>
-              </a:rPr>
-              <a:t>PHYSICS FRAMING</a:t>
+            <a:pPr algn="r">
+              <a:spcAft>
+                <a:spcPts val="550"/>
+              </a:spcAft>
+            </a:pPr>
+            <a:r>
+              <a:rPr sz="1100" b="0">
+                <a:solidFill>
+                  <a:srgbClr val="A8A8A8"/>
+                </a:solidFill>
+                <a:latin typeface="Calibri"/>
+              </a:rPr>
+              <a:t>3 / 12</a:t>
             </a:r>
           </a:p>
         </p:txBody>
@@ -4862,8 +5620,8 @@
         </p:nvSpPr>
         <p:spPr>
           <a:xfrm>
-            <a:off x="548640" y="640080"/>
-            <a:ext cx="11155680" cy="822960"/>
+            <a:off x="548640" y="320040"/>
+            <a:ext cx="10972800" cy="365760"/>
           </a:xfrm>
           <a:prstGeom prst="rect">
             <a:avLst/>
@@ -4878,17 +5636,17 @@
           <a:p>
             <a:pPr algn="l">
               <a:spcAft>
-                <a:spcPts val="1600"/>
-              </a:spcAft>
-            </a:pPr>
-            <a:r>
-              <a:rPr sz="3200" b="1">
-                <a:solidFill>
-                  <a:srgbClr val="F2F2F2"/>
-                </a:solidFill>
-                <a:latin typeface="Calibri"/>
-              </a:rPr>
-              <a:t>Energy balance: Q ≈ UA · ΔT summed over the year</a:t>
+                <a:spcPts val="650"/>
+              </a:spcAft>
+            </a:pPr>
+            <a:r>
+              <a:rPr sz="1300" b="1">
+                <a:solidFill>
+                  <a:srgbClr val="E07B39"/>
+                </a:solidFill>
+                <a:latin typeface="Calibri"/>
+              </a:rPr>
+              <a:t>DATA MASTERY · 3 FINDINGS</a:t>
             </a:r>
           </a:p>
         </p:txBody>
@@ -4901,8 +5659,8 @@
         </p:nvSpPr>
         <p:spPr>
           <a:xfrm>
-            <a:off x="548640" y="1828800"/>
-            <a:ext cx="4206240" cy="4389120"/>
+            <a:off x="548640" y="640080"/>
+            <a:ext cx="11155680" cy="822960"/>
           </a:xfrm>
           <a:prstGeom prst="rect">
             <a:avLst/>
@@ -4917,72 +5675,111 @@
           <a:p>
             <a:pPr algn="l">
               <a:spcAft>
-                <a:spcPts val="1000"/>
-              </a:spcAft>
-            </a:pPr>
-            <a:r>
-              <a:rPr sz="2000" b="0">
+                <a:spcPts val="1600"/>
+              </a:spcAft>
+            </a:pPr>
+            <a:r>
+              <a:rPr sz="3200" b="1">
                 <a:solidFill>
                   <a:srgbClr val="F2F2F2"/>
                 </a:solidFill>
                 <a:latin typeface="Calibri"/>
               </a:rPr>
-              <a:t>Heating demand scales with heating degree days, cooling with cooling degree days.</a:t>
-            </a:r>
-          </a:p>
+              <a:t>Finding 1: the test set comes from different states</a:t>
+            </a:r>
+          </a:p>
+        </p:txBody>
+      </p:sp>
+      <p:sp>
+        <p:nvSpPr>
+          <p:cNvPr id="5" name="TextBox 4"/>
+          <p:cNvSpPr txBox="1"/>
+          <p:nvPr/>
+        </p:nvSpPr>
+        <p:spPr>
+          <a:xfrm>
+            <a:off x="548640" y="1828800"/>
+            <a:ext cx="4389120" cy="4389120"/>
+          </a:xfrm>
+          <a:prstGeom prst="rect">
+            <a:avLst/>
+          </a:prstGeom>
+          <a:noFill/>
+        </p:spPr>
+        <p:txBody>
+          <a:bodyPr wrap="square">
+            <a:spAutoFit/>
+          </a:bodyPr>
+          <a:lstStyle/>
           <a:p>
             <a:pPr algn="l">
               <a:spcAft>
-                <a:spcPts val="900"/>
-              </a:spcAft>
-            </a:pPr>
-            <a:r>
-              <a:rPr sz="1800" b="1">
+                <a:spcPts val="1100"/>
+              </a:spcAft>
+            </a:pPr>
+            <a:r>
+              <a:rPr sz="2200" b="1">
+                <a:solidFill>
+                  <a:srgbClr val="A8A8A8"/>
+                </a:solidFill>
+                <a:latin typeface="Calibri"/>
+              </a:rPr>
+              <a:t>State_6</a:t>
+            </a:r>
+          </a:p>
+          <a:p>
+            <a:pPr algn="l">
+              <a:spcAft>
+                <a:spcPts val="1800"/>
+              </a:spcAft>
+            </a:pPr>
+            <a:r>
+              <a:rPr sz="3600" b="1">
+                <a:solidFill>
+                  <a:srgbClr val="4A9BE8"/>
+                </a:solidFill>
+                <a:latin typeface="Calibri"/>
+              </a:rPr>
+              <a:t>67.1% of train</a:t>
+            </a:r>
+          </a:p>
+          <a:p>
+            <a:pPr algn="l">
+              <a:spcAft>
+                <a:spcPts val="1800"/>
+              </a:spcAft>
+            </a:pPr>
+            <a:r>
+              <a:rPr sz="3600" b="1">
                 <a:solidFill>
                   <a:srgbClr val="E07B39"/>
                 </a:solidFill>
                 <a:latin typeface="Calibri"/>
               </a:rPr>
-              <a:t>Features we engineered:</a:t>
+              <a:t>0% of test</a:t>
             </a:r>
           </a:p>
           <a:p>
             <a:pPr algn="l">
               <a:spcAft>
-                <a:spcPts val="900"/>
-              </a:spcAft>
-            </a:pPr>
-            <a:r>
-              <a:rPr sz="1800" b="0">
+                <a:spcPts val="950"/>
+              </a:spcAft>
+            </a:pPr>
+            <a:r>
+              <a:rPr sz="1900" b="0">
                 <a:solidFill>
                   <a:srgbClr val="F2F2F2"/>
                 </a:solidFill>
                 <a:latin typeface="Calibri"/>
               </a:rPr>
-              <a:t>winter &amp; summer mean temperature · annual temperature range · total degree days · cooling share · log floor area · building age</a:t>
-            </a:r>
-          </a:p>
-          <a:p>
-            <a:pPr algn="l">
-              <a:spcAft>
-                <a:spcPts val="900"/>
-              </a:spcAft>
-            </a:pPr>
-            <a:r>
-              <a:rPr sz="1800" b="0">
-                <a:solidFill>
-                  <a:srgbClr val="A8A8A8"/>
-                </a:solidFill>
-                <a:latin typeface="Calibri"/>
-              </a:rPr>
-              <a:t>Raw data: median EUI ≈ 36–53 in milder climates vs ≈ 68–82 in colder ones.</a:t>
+              <a:t>→ we also report a test-like score on non-State_6 buildings</a:t>
             </a:r>
           </a:p>
         </p:txBody>
       </p:sp>
       <p:pic>
         <p:nvPicPr>
-          <p:cNvPr id="5" name="Picture 4" descr="05_eui_vs_hdd.png"/>
+          <p:cNvPr id="6" name="Picture 5" descr="02_state_shift.png"/>
           <p:cNvPicPr>
             <a:picLocks noChangeAspect="1"/>
           </p:cNvPicPr>
@@ -4996,8 +5793,8 @@
         </p:blipFill>
         <p:spPr>
           <a:xfrm>
-            <a:off x="4937760" y="1733973"/>
-            <a:ext cx="6766560" cy="4761653"/>
+            <a:off x="5120640" y="2347667"/>
+            <a:ext cx="6675120" cy="3534266"/>
           </a:xfrm>
           <a:prstGeom prst="rect">
             <a:avLst/>
@@ -5038,8 +5835,8 @@
         </p:nvSpPr>
         <p:spPr>
           <a:xfrm>
-            <a:off x="548640" y="320040"/>
-            <a:ext cx="10972800" cy="365760"/>
+            <a:off x="10789920" y="6400800"/>
+            <a:ext cx="1188720" cy="365760"/>
           </a:xfrm>
           <a:prstGeom prst="rect">
             <a:avLst/>
@@ -5052,19 +5849,19 @@
           </a:bodyPr>
           <a:lstStyle/>
           <a:p>
-            <a:pPr algn="l">
-              <a:spcAft>
-                <a:spcPts val="650"/>
-              </a:spcAft>
-            </a:pPr>
-            <a:r>
-              <a:rPr sz="1300" b="1">
-                <a:solidFill>
-                  <a:srgbClr val="E07B39"/>
-                </a:solidFill>
-                <a:latin typeface="Calibri"/>
-              </a:rPr>
-              <a:t>DATA MASTERY</a:t>
+            <a:pPr algn="r">
+              <a:spcAft>
+                <a:spcPts val="550"/>
+              </a:spcAft>
+            </a:pPr>
+            <a:r>
+              <a:rPr sz="1100" b="0">
+                <a:solidFill>
+                  <a:srgbClr val="A8A8A8"/>
+                </a:solidFill>
+                <a:latin typeface="Calibri"/>
+              </a:rPr>
+              <a:t>4 / 12</a:t>
             </a:r>
           </a:p>
         </p:txBody>
@@ -5077,8 +5874,8 @@
         </p:nvSpPr>
         <p:spPr>
           <a:xfrm>
-            <a:off x="548640" y="640080"/>
-            <a:ext cx="11155680" cy="822960"/>
+            <a:off x="548640" y="320040"/>
+            <a:ext cx="10972800" cy="365760"/>
           </a:xfrm>
           <a:prstGeom prst="rect">
             <a:avLst/>
@@ -5093,17 +5890,17 @@
           <a:p>
             <a:pPr algn="l">
               <a:spcAft>
-                <a:spcPts val="1600"/>
-              </a:spcAft>
-            </a:pPr>
-            <a:r>
-              <a:rPr sz="3200" b="1">
-                <a:solidFill>
-                  <a:srgbClr val="F2F2F2"/>
-                </a:solidFill>
-                <a:latin typeface="Calibri"/>
-              </a:rPr>
-              <a:t>Three findings that shaped the whole design</a:t>
+                <a:spcPts val="650"/>
+              </a:spcAft>
+            </a:pPr>
+            <a:r>
+              <a:rPr sz="1300" b="1">
+                <a:solidFill>
+                  <a:srgbClr val="E07B39"/>
+                </a:solidFill>
+                <a:latin typeface="Calibri"/>
+              </a:rPr>
+              <a:t>DATA MASTERY · 3 FINDINGS</a:t>
             </a:r>
           </a:p>
         </p:txBody>
@@ -5116,8 +5913,8 @@
         </p:nvSpPr>
         <p:spPr>
           <a:xfrm>
-            <a:off x="548640" y="1737360"/>
-            <a:ext cx="4572000" cy="4846320"/>
+            <a:off x="548640" y="640080"/>
+            <a:ext cx="11155680" cy="822960"/>
           </a:xfrm>
           <a:prstGeom prst="rect">
             <a:avLst/>
@@ -5132,125 +5929,209 @@
           <a:p>
             <a:pPr algn="l">
               <a:spcAft>
-                <a:spcPts val="1000"/>
-              </a:spcAft>
-            </a:pPr>
-            <a:r>
-              <a:rPr sz="2000" b="1">
-                <a:solidFill>
-                  <a:srgbClr val="E07B39"/>
-                </a:solidFill>
-                <a:latin typeface="Calibri"/>
-              </a:rPr>
-              <a:t>1  Distribution shift</a:t>
-            </a:r>
-          </a:p>
-          <a:p>
-            <a:pPr algn="l">
-              <a:spcAft>
-                <a:spcPts val="900"/>
-              </a:spcAft>
-            </a:pPr>
-            <a:r>
-              <a:rPr sz="1800" b="0">
+                <a:spcPts val="1600"/>
+              </a:spcAft>
+            </a:pPr>
+            <a:r>
+              <a:rPr sz="3200" b="1">
                 <a:solidFill>
                   <a:srgbClr val="F2F2F2"/>
                 </a:solidFill>
                 <a:latin typeface="Calibri"/>
               </a:rPr>
-              <a:t>State_6 is 67.1% of train but 0% of test → we also report a test-like score.</a:t>
-            </a:r>
-          </a:p>
-          <a:p>
-            <a:pPr algn="l">
-              <a:spcAft>
-                <a:spcPts val="1000"/>
-              </a:spcAft>
-            </a:pPr>
-            <a:r>
-              <a:rPr sz="2000" b="1">
-                <a:solidFill>
-                  <a:srgbClr val="E07B39"/>
-                </a:solidFill>
-                <a:latin typeface="Calibri"/>
-              </a:rPr>
-              <a:t>2  Missingness shift</a:t>
-            </a:r>
-          </a:p>
-          <a:p>
-            <a:pPr algn="l">
-              <a:spcAft>
-                <a:spcPts val="900"/>
-              </a:spcAft>
-            </a:pPr>
-            <a:r>
-              <a:rPr sz="1800" b="0">
-                <a:solidFill>
-                  <a:srgbClr val="F2F2F2"/>
-                </a:solidFill>
-                <a:latin typeface="Calibri"/>
-              </a:rPr>
-              <a:t>Wind/fog 56.0% missing in train vs 89.8% in test → dropped.</a:t>
-            </a:r>
-          </a:p>
-          <a:p>
-            <a:pPr algn="l">
-              <a:spcAft>
-                <a:spcPts val="1000"/>
-              </a:spcAft>
-            </a:pPr>
-            <a:r>
-              <a:rPr sz="2000" b="1">
-                <a:solidFill>
-                  <a:srgbClr val="E07B39"/>
-                </a:solidFill>
-                <a:latin typeface="Calibri"/>
-              </a:rPr>
-              <a:t>3  Hidden building identity</a:t>
-            </a:r>
-          </a:p>
-          <a:p>
-            <a:pPr algn="l">
-              <a:spcAft>
-                <a:spcPts val="900"/>
-              </a:spcAft>
-            </a:pPr>
-            <a:r>
-              <a:rPr sz="1800" b="0">
-                <a:solidFill>
-                  <a:srgbClr val="F2F2F2"/>
-                </a:solidFill>
-                <a:latin typeface="Calibri"/>
-              </a:rPr>
-              <a:t>Reconstructed 63,907 buildings → past energy use as a feature, from earlier years only (unit-tested).</a:t>
-            </a:r>
-          </a:p>
-        </p:txBody>
-      </p:sp>
-      <p:pic>
-        <p:nvPicPr>
-          <p:cNvPr id="5" name="Picture 4" descr="02_state_shift.png"/>
-          <p:cNvPicPr>
-            <a:picLocks noChangeAspect="1"/>
-          </p:cNvPicPr>
+              <a:t>Finding 2: missingness shifts between train and test</a:t>
+            </a:r>
+          </a:p>
+        </p:txBody>
+      </p:sp>
+      <p:sp>
+        <p:nvSpPr>
+          <p:cNvPr id="5" name="TextBox 4"/>
+          <p:cNvSpPr txBox="1"/>
           <p:nvPr/>
-        </p:nvPicPr>
-        <p:blipFill>
-          <a:blip r:embed="rId3"/>
-          <a:stretch>
-            <a:fillRect/>
-          </a:stretch>
-        </p:blipFill>
-        <p:spPr>
-          <a:xfrm>
-            <a:off x="5303520" y="2396081"/>
-            <a:ext cx="6492240" cy="3437437"/>
+        </p:nvSpPr>
+        <p:spPr>
+          <a:xfrm>
+            <a:off x="731520" y="1920240"/>
+            <a:ext cx="10698480" cy="548640"/>
           </a:xfrm>
           <a:prstGeom prst="rect">
             <a:avLst/>
           </a:prstGeom>
-        </p:spPr>
-      </p:pic>
+          <a:noFill/>
+        </p:spPr>
+        <p:txBody>
+          <a:bodyPr wrap="square">
+            <a:spAutoFit/>
+          </a:bodyPr>
+          <a:lstStyle/>
+          <a:p>
+            <a:pPr algn="ctr">
+              <a:spcAft>
+                <a:spcPts val="1200"/>
+              </a:spcAft>
+            </a:pPr>
+            <a:r>
+              <a:rPr sz="2400" b="0">
+                <a:solidFill>
+                  <a:srgbClr val="A8A8A8"/>
+                </a:solidFill>
+                <a:latin typeface="Calibri"/>
+              </a:rPr>
+              <a:t>Wind and fog columns, share missing</a:t>
+            </a:r>
+          </a:p>
+        </p:txBody>
+      </p:sp>
+      <p:sp>
+        <p:nvSpPr>
+          <p:cNvPr id="6" name="TextBox 5"/>
+          <p:cNvSpPr txBox="1"/>
+          <p:nvPr/>
+        </p:nvSpPr>
+        <p:spPr>
+          <a:xfrm>
+            <a:off x="731520" y="2651760"/>
+            <a:ext cx="5120640" cy="1463040"/>
+          </a:xfrm>
+          <a:prstGeom prst="rect">
+            <a:avLst/>
+          </a:prstGeom>
+          <a:noFill/>
+        </p:spPr>
+        <p:txBody>
+          <a:bodyPr wrap="square">
+            <a:spAutoFit/>
+          </a:bodyPr>
+          <a:lstStyle/>
+          <a:p>
+            <a:pPr algn="ctr">
+              <a:spcAft>
+                <a:spcPts val="3600"/>
+              </a:spcAft>
+            </a:pPr>
+            <a:r>
+              <a:rPr sz="7200" b="1">
+                <a:solidFill>
+                  <a:srgbClr val="4A9BE8"/>
+                </a:solidFill>
+                <a:latin typeface="Calibri"/>
+              </a:rPr>
+              <a:t>56.0%</a:t>
+            </a:r>
+          </a:p>
+          <a:p>
+            <a:pPr algn="ctr">
+              <a:spcAft>
+                <a:spcPts val="1000"/>
+              </a:spcAft>
+            </a:pPr>
+            <a:r>
+              <a:rPr sz="2000" b="0">
+                <a:solidFill>
+                  <a:srgbClr val="A8A8A8"/>
+                </a:solidFill>
+                <a:latin typeface="Calibri"/>
+              </a:rPr>
+              <a:t>train</a:t>
+            </a:r>
+          </a:p>
+        </p:txBody>
+      </p:sp>
+      <p:sp>
+        <p:nvSpPr>
+          <p:cNvPr id="7" name="TextBox 6"/>
+          <p:cNvSpPr txBox="1"/>
+          <p:nvPr/>
+        </p:nvSpPr>
+        <p:spPr>
+          <a:xfrm>
+            <a:off x="6309360" y="2651760"/>
+            <a:ext cx="5120640" cy="1463040"/>
+          </a:xfrm>
+          <a:prstGeom prst="rect">
+            <a:avLst/>
+          </a:prstGeom>
+          <a:noFill/>
+        </p:spPr>
+        <p:txBody>
+          <a:bodyPr wrap="square">
+            <a:spAutoFit/>
+          </a:bodyPr>
+          <a:lstStyle/>
+          <a:p>
+            <a:pPr algn="ctr">
+              <a:spcAft>
+                <a:spcPts val="3600"/>
+              </a:spcAft>
+            </a:pPr>
+            <a:r>
+              <a:rPr sz="7200" b="1">
+                <a:solidFill>
+                  <a:srgbClr val="E07B39"/>
+                </a:solidFill>
+                <a:latin typeface="Calibri"/>
+              </a:rPr>
+              <a:t>89.8%</a:t>
+            </a:r>
+          </a:p>
+          <a:p>
+            <a:pPr algn="ctr">
+              <a:spcAft>
+                <a:spcPts val="1000"/>
+              </a:spcAft>
+            </a:pPr>
+            <a:r>
+              <a:rPr sz="2000" b="0">
+                <a:solidFill>
+                  <a:srgbClr val="A8A8A8"/>
+                </a:solidFill>
+                <a:latin typeface="Calibri"/>
+              </a:rPr>
+              <a:t>test</a:t>
+            </a:r>
+          </a:p>
+        </p:txBody>
+      </p:sp>
+      <p:sp>
+        <p:nvSpPr>
+          <p:cNvPr id="8" name="TextBox 7"/>
+          <p:cNvSpPr txBox="1"/>
+          <p:nvPr/>
+        </p:nvSpPr>
+        <p:spPr>
+          <a:xfrm>
+            <a:off x="731520" y="5120640"/>
+            <a:ext cx="10698480" cy="914400"/>
+          </a:xfrm>
+          <a:prstGeom prst="rect">
+            <a:avLst/>
+          </a:prstGeom>
+          <a:noFill/>
+        </p:spPr>
+        <p:txBody>
+          <a:bodyPr wrap="square">
+            <a:spAutoFit/>
+          </a:bodyPr>
+          <a:lstStyle/>
+          <a:p>
+            <a:pPr algn="ctr">
+              <a:spcAft>
+                <a:spcPts val="1200"/>
+              </a:spcAft>
+            </a:pPr>
+            <a:r>
+              <a:rPr sz="2400" b="1">
+                <a:solidFill>
+                  <a:srgbClr val="F2F2F2"/>
+                </a:solidFill>
+                <a:latin typeface="Calibri"/>
+              </a:rPr>
+              <a:t>A model would learn a pattern that doesn't exist at test time → dropped</a:t>
+            </a:r>
+          </a:p>
+        </p:txBody>
+      </p:sp>
     </p:spTree>
   </p:cSld>
   <p:clrMapOvr>
@@ -5285,8 +6166,8 @@
         </p:nvSpPr>
         <p:spPr>
           <a:xfrm>
-            <a:off x="548640" y="320040"/>
-            <a:ext cx="10972800" cy="365760"/>
+            <a:off x="10789920" y="6400800"/>
+            <a:ext cx="1188720" cy="365760"/>
           </a:xfrm>
           <a:prstGeom prst="rect">
             <a:avLst/>
@@ -5299,19 +6180,19 @@
           </a:bodyPr>
           <a:lstStyle/>
           <a:p>
-            <a:pPr algn="l">
-              <a:spcAft>
-                <a:spcPts val="650"/>
-              </a:spcAft>
-            </a:pPr>
-            <a:r>
-              <a:rPr sz="1300" b="1">
-                <a:solidFill>
-                  <a:srgbClr val="E07B39"/>
-                </a:solidFill>
-                <a:latin typeface="Calibri"/>
-              </a:rPr>
-              <a:t>HONEST VALIDATION</a:t>
+            <a:pPr algn="r">
+              <a:spcAft>
+                <a:spcPts val="550"/>
+              </a:spcAft>
+            </a:pPr>
+            <a:r>
+              <a:rPr sz="1100" b="0">
+                <a:solidFill>
+                  <a:srgbClr val="A8A8A8"/>
+                </a:solidFill>
+                <a:latin typeface="Calibri"/>
+              </a:rPr>
+              <a:t>5 / 12</a:t>
             </a:r>
           </a:p>
         </p:txBody>
@@ -5324,8 +6205,8 @@
         </p:nvSpPr>
         <p:spPr>
           <a:xfrm>
-            <a:off x="548640" y="640080"/>
-            <a:ext cx="11155680" cy="822960"/>
+            <a:off x="548640" y="320040"/>
+            <a:ext cx="10972800" cy="365760"/>
           </a:xfrm>
           <a:prstGeom prst="rect">
             <a:avLst/>
@@ -5340,17 +6221,17 @@
           <a:p>
             <a:pPr algn="l">
               <a:spcAft>
-                <a:spcPts val="1600"/>
-              </a:spcAft>
-            </a:pPr>
-            <a:r>
-              <a:rPr sz="3200" b="1">
-                <a:solidFill>
-                  <a:srgbClr val="F2F2F2"/>
-                </a:solidFill>
-                <a:latin typeface="Calibri"/>
-              </a:rPr>
-              <a:t>Validate the way the task works: train on the past, predict an unseen year</a:t>
+                <a:spcPts val="650"/>
+              </a:spcAft>
+            </a:pPr>
+            <a:r>
+              <a:rPr sz="1300" b="1">
+                <a:solidFill>
+                  <a:srgbClr val="E07B39"/>
+                </a:solidFill>
+                <a:latin typeface="Calibri"/>
+              </a:rPr>
+              <a:t>DATA MASTERY · 3 FINDINGS</a:t>
             </a:r>
           </a:p>
         </p:txBody>
@@ -5363,8 +6244,8 @@
         </p:nvSpPr>
         <p:spPr>
           <a:xfrm>
-            <a:off x="548640" y="1828800"/>
-            <a:ext cx="4389120" cy="4389120"/>
+            <a:off x="548640" y="640080"/>
+            <a:ext cx="11155680" cy="822960"/>
           </a:xfrm>
           <a:prstGeom prst="rect">
             <a:avLst/>
@@ -5379,125 +6260,163 @@
           <a:p>
             <a:pPr algn="l">
               <a:spcAft>
-                <a:spcPts val="1100"/>
-              </a:spcAft>
-            </a:pPr>
-            <a:r>
-              <a:rPr sz="2200" b="1">
+                <a:spcPts val="1600"/>
+              </a:spcAft>
+            </a:pPr>
+            <a:r>
+              <a:rPr sz="3200" b="1">
                 <a:solidFill>
                   <a:srgbClr val="F2F2F2"/>
                 </a:solidFill>
                 <a:latin typeface="Calibri"/>
               </a:rPr>
-              <a:t>Train: years 1–5</a:t>
-            </a:r>
-          </a:p>
-          <a:p>
-            <a:pPr algn="l">
-              <a:spcAft>
-                <a:spcPts val="1100"/>
-              </a:spcAft>
-            </a:pPr>
-            <a:r>
-              <a:rPr sz="2200" b="1">
-                <a:solidFill>
-                  <a:srgbClr val="F2F2F2"/>
-                </a:solidFill>
-                <a:latin typeface="Calibri"/>
-              </a:rPr>
-              <a:t>Validate: year 6 (test is year 7)</a:t>
-            </a:r>
-          </a:p>
-          <a:p>
-            <a:pPr algn="l">
-              <a:spcAft>
-                <a:spcPts val="900"/>
-              </a:spcAft>
-            </a:pPr>
-            <a:r>
-              <a:rPr sz="1800" b="0">
-                <a:solidFill>
-                  <a:srgbClr val="A8A8A8"/>
-                </a:solidFill>
-                <a:latin typeface="Calibri"/>
-              </a:rPr>
-              <a:t>Same model, same features:</a:t>
-            </a:r>
-          </a:p>
-          <a:p>
-            <a:pPr algn="l">
-              <a:spcAft>
-                <a:spcPts val="1300"/>
-              </a:spcAft>
-            </a:pPr>
-            <a:r>
-              <a:rPr sz="2600" b="1">
-                <a:solidFill>
-                  <a:srgbClr val="4A9BE8"/>
-                </a:solidFill>
-                <a:latin typeface="Calibri"/>
-              </a:rPr>
-              <a:t>Random split   37.9</a:t>
-            </a:r>
-          </a:p>
-          <a:p>
-            <a:pPr algn="l">
-              <a:spcAft>
-                <a:spcPts val="1300"/>
-              </a:spcAft>
-            </a:pPr>
-            <a:r>
-              <a:rPr sz="2600" b="1">
-                <a:solidFill>
-                  <a:srgbClr val="E07B39"/>
-                </a:solidFill>
-                <a:latin typeface="Calibri"/>
-              </a:rPr>
-              <a:t>Temporal split  42.5</a:t>
-            </a:r>
-          </a:p>
-          <a:p>
-            <a:pPr algn="l">
-              <a:spcAft>
-                <a:spcPts val="900"/>
-              </a:spcAft>
-            </a:pPr>
-            <a:r>
-              <a:rPr sz="1800" b="0">
-                <a:solidFill>
-                  <a:srgbClr val="F2F2F2"/>
-                </a:solidFill>
-                <a:latin typeface="Calibri"/>
-              </a:rPr>
-              <a:t>A random split flatters by ~12%: other years of the same building leak into training.</a:t>
-            </a:r>
-          </a:p>
-        </p:txBody>
-      </p:sp>
-      <p:pic>
-        <p:nvPicPr>
-          <p:cNvPr id="5" name="Picture 4" descr="09_validation_schemes.png"/>
-          <p:cNvPicPr>
-            <a:picLocks noChangeAspect="1"/>
-          </p:cNvPicPr>
+              <a:t>Finding 3: the same buildings recur, but without an id</a:t>
+            </a:r>
+          </a:p>
+        </p:txBody>
+      </p:sp>
+      <p:sp>
+        <p:nvSpPr>
+          <p:cNvPr id="5" name="TextBox 4"/>
+          <p:cNvSpPr txBox="1"/>
           <p:nvPr/>
-        </p:nvPicPr>
-        <p:blipFill>
-          <a:blip r:embed="rId3"/>
-          <a:stretch>
-            <a:fillRect/>
-          </a:stretch>
-        </p:blipFill>
-        <p:spPr>
-          <a:xfrm>
-            <a:off x="5120640" y="1991419"/>
-            <a:ext cx="6583680" cy="4338202"/>
+        </p:nvSpPr>
+        <p:spPr>
+          <a:xfrm>
+            <a:off x="731520" y="1828800"/>
+            <a:ext cx="5303520" cy="4389120"/>
           </a:xfrm>
           <a:prstGeom prst="rect">
             <a:avLst/>
           </a:prstGeom>
-        </p:spPr>
-      </p:pic>
+          <a:noFill/>
+        </p:spPr>
+        <p:txBody>
+          <a:bodyPr wrap="square">
+            <a:spAutoFit/>
+          </a:bodyPr>
+          <a:lstStyle/>
+          <a:p>
+            <a:pPr algn="l">
+              <a:spcAft>
+                <a:spcPts val="3600"/>
+              </a:spcAft>
+            </a:pPr>
+            <a:r>
+              <a:rPr sz="7200" b="1">
+                <a:solidFill>
+                  <a:srgbClr val="E07B39"/>
+                </a:solidFill>
+                <a:latin typeface="Calibri"/>
+              </a:rPr>
+              <a:t>63,907</a:t>
+            </a:r>
+          </a:p>
+          <a:p>
+            <a:pPr algn="l">
+              <a:spcAft>
+                <a:spcPts val="1000"/>
+              </a:spcAft>
+            </a:pPr>
+            <a:r>
+              <a:rPr sz="2000" b="0">
+                <a:solidFill>
+                  <a:srgbClr val="F2F2F2"/>
+                </a:solidFill>
+                <a:latin typeface="Calibri"/>
+              </a:rPr>
+              <a:t>buildings reconstructed from static attributes</a:t>
+            </a:r>
+          </a:p>
+          <a:p>
+            <a:pPr algn="l">
+              <a:spcAft>
+                <a:spcPts val="850"/>
+              </a:spcAft>
+            </a:pPr>
+            <a:r>
+              <a:rPr sz="1700" b="0">
+                <a:solidFill>
+                  <a:srgbClr val="A8A8A8"/>
+                </a:solidFill>
+                <a:latin typeface="Calibri"/>
+              </a:rPr>
+              <a:t>state · class · facility type · floor area · year built · elevation</a:t>
+            </a:r>
+          </a:p>
+        </p:txBody>
+      </p:sp>
+      <p:sp>
+        <p:nvSpPr>
+          <p:cNvPr id="6" name="TextBox 5"/>
+          <p:cNvSpPr txBox="1"/>
+          <p:nvPr/>
+        </p:nvSpPr>
+        <p:spPr>
+          <a:xfrm>
+            <a:off x="6400800" y="1828800"/>
+            <a:ext cx="5303520" cy="4389120"/>
+          </a:xfrm>
+          <a:prstGeom prst="rect">
+            <a:avLst/>
+          </a:prstGeom>
+          <a:noFill/>
+        </p:spPr>
+        <p:txBody>
+          <a:bodyPr wrap="square">
+            <a:spAutoFit/>
+          </a:bodyPr>
+          <a:lstStyle/>
+          <a:p>
+            <a:pPr algn="l">
+              <a:spcAft>
+                <a:spcPts val="1200"/>
+              </a:spcAft>
+            </a:pPr>
+            <a:r>
+              <a:rPr sz="2400" b="1">
+                <a:solidFill>
+                  <a:srgbClr val="F2F2F2"/>
+                </a:solidFill>
+                <a:latin typeface="Calibri"/>
+              </a:rPr>
+              <a:t>Past energy use becomes a feature</a:t>
+            </a:r>
+          </a:p>
+          <a:p>
+            <a:pPr algn="l">
+              <a:spcAft>
+                <a:spcPts val="1000"/>
+              </a:spcAft>
+            </a:pPr>
+            <a:r>
+              <a:rPr sz="2000" b="0">
+                <a:solidFill>
+                  <a:srgbClr val="F2F2F2"/>
+                </a:solidFill>
+                <a:latin typeface="Calibri"/>
+              </a:rPr>
+              <a:t>Computed only from earlier years: no leakage, proven by a unit test</a:t>
+            </a:r>
+          </a:p>
+          <a:p>
+            <a:pPr algn="l">
+              <a:spcAft>
+                <a:spcPts val="1100"/>
+              </a:spcAft>
+            </a:pPr>
+            <a:r>
+              <a:rPr sz="2200" b="1">
+                <a:solidFill>
+                  <a:srgbClr val="E07B39"/>
+                </a:solidFill>
+                <a:latin typeface="Calibri"/>
+              </a:rPr>
+              <a:t>22.1% of test rows have past energy data</a:t>
+            </a:r>
+          </a:p>
+        </p:txBody>
+      </p:sp>
     </p:spTree>
   </p:cSld>
   <p:clrMapOvr>
@@ -5532,8 +6451,8 @@
         </p:nvSpPr>
         <p:spPr>
           <a:xfrm>
-            <a:off x="548640" y="320040"/>
-            <a:ext cx="10972800" cy="365760"/>
+            <a:off x="10789920" y="6400800"/>
+            <a:ext cx="1188720" cy="365760"/>
           </a:xfrm>
           <a:prstGeom prst="rect">
             <a:avLst/>
@@ -5546,19 +6465,19 @@
           </a:bodyPr>
           <a:lstStyle/>
           <a:p>
-            <a:pPr algn="l">
-              <a:spcAft>
-                <a:spcPts val="650"/>
-              </a:spcAft>
-            </a:pPr>
-            <a:r>
-              <a:rPr sz="1300" b="1">
-                <a:solidFill>
-                  <a:srgbClr val="E07B39"/>
-                </a:solidFill>
-                <a:latin typeface="Calibri"/>
-              </a:rPr>
-              <a:t>USE OF MACHINE LEARNING</a:t>
+            <a:pPr algn="r">
+              <a:spcAft>
+                <a:spcPts val="550"/>
+              </a:spcAft>
+            </a:pPr>
+            <a:r>
+              <a:rPr sz="1100" b="0">
+                <a:solidFill>
+                  <a:srgbClr val="A8A8A8"/>
+                </a:solidFill>
+                <a:latin typeface="Calibri"/>
+              </a:rPr>
+              <a:t>6 / 12</a:t>
             </a:r>
           </a:p>
         </p:txBody>
@@ -5571,8 +6490,8 @@
         </p:nvSpPr>
         <p:spPr>
           <a:xfrm>
-            <a:off x="548640" y="640080"/>
-            <a:ext cx="11155680" cy="822960"/>
+            <a:off x="548640" y="320040"/>
+            <a:ext cx="10972800" cy="365760"/>
           </a:xfrm>
           <a:prstGeom prst="rect">
             <a:avLst/>
@@ -5587,6 +6506,45 @@
           <a:p>
             <a:pPr algn="l">
               <a:spcAft>
+                <a:spcPts val="650"/>
+              </a:spcAft>
+            </a:pPr>
+            <a:r>
+              <a:rPr sz="1300" b="1">
+                <a:solidFill>
+                  <a:srgbClr val="E07B39"/>
+                </a:solidFill>
+                <a:latin typeface="Calibri"/>
+              </a:rPr>
+              <a:t>HONEST VALIDATION</a:t>
+            </a:r>
+          </a:p>
+        </p:txBody>
+      </p:sp>
+      <p:sp>
+        <p:nvSpPr>
+          <p:cNvPr id="4" name="TextBox 3"/>
+          <p:cNvSpPr txBox="1"/>
+          <p:nvPr/>
+        </p:nvSpPr>
+        <p:spPr>
+          <a:xfrm>
+            <a:off x="548640" y="640080"/>
+            <a:ext cx="11155680" cy="822960"/>
+          </a:xfrm>
+          <a:prstGeom prst="rect">
+            <a:avLst/>
+          </a:prstGeom>
+          <a:noFill/>
+        </p:spPr>
+        <p:txBody>
+          <a:bodyPr wrap="square">
+            <a:spAutoFit/>
+          </a:bodyPr>
+          <a:lstStyle/>
+          <a:p>
+            <a:pPr algn="l">
+              <a:spcAft>
                 <a:spcPts val="1600"/>
               </a:spcAft>
             </a:pPr>
@@ -5597,14 +6555,117 @@
                 </a:solidFill>
                 <a:latin typeface="Calibri"/>
               </a:rPr>
-              <a:t>10-model ladder: each rung answers one question</a:t>
+              <a:t>Validate the way the task works</a:t>
+            </a:r>
+          </a:p>
+        </p:txBody>
+      </p:sp>
+      <p:sp>
+        <p:nvSpPr>
+          <p:cNvPr id="5" name="TextBox 4"/>
+          <p:cNvSpPr txBox="1"/>
+          <p:nvPr/>
+        </p:nvSpPr>
+        <p:spPr>
+          <a:xfrm>
+            <a:off x="548640" y="1828800"/>
+            <a:ext cx="4389120" cy="4389120"/>
+          </a:xfrm>
+          <a:prstGeom prst="rect">
+            <a:avLst/>
+          </a:prstGeom>
+          <a:noFill/>
+        </p:spPr>
+        <p:txBody>
+          <a:bodyPr wrap="square">
+            <a:spAutoFit/>
+          </a:bodyPr>
+          <a:lstStyle/>
+          <a:p>
+            <a:pPr algn="l">
+              <a:spcAft>
+                <a:spcPts val="1050"/>
+              </a:spcAft>
+            </a:pPr>
+            <a:r>
+              <a:rPr sz="2100" b="1">
+                <a:solidFill>
+                  <a:srgbClr val="F2F2F2"/>
+                </a:solidFill>
+                <a:latin typeface="Calibri"/>
+              </a:rPr>
+              <a:t>Train years 1–5 → predict year 6, never seen</a:t>
+            </a:r>
+          </a:p>
+          <a:p>
+            <a:pPr algn="l">
+              <a:spcAft>
+                <a:spcPts val="900"/>
+              </a:spcAft>
+            </a:pPr>
+            <a:r>
+              <a:rPr sz="1800" b="0">
+                <a:solidFill>
+                  <a:srgbClr val="A8A8A8"/>
+                </a:solidFill>
+                <a:latin typeface="Calibri"/>
+              </a:rPr>
+              <a:t>Same model, same features:</a:t>
+            </a:r>
+          </a:p>
+          <a:p>
+            <a:pPr algn="l">
+              <a:spcAft>
+                <a:spcPts val="1400"/>
+              </a:spcAft>
+            </a:pPr>
+            <a:r>
+              <a:rPr sz="2800" b="1">
+                <a:solidFill>
+                  <a:srgbClr val="4A9BE8"/>
+                </a:solidFill>
+                <a:latin typeface="Calibri"/>
+              </a:rPr>
+              <a:t>Random split   37.9</a:t>
+            </a:r>
+          </a:p>
+          <a:p>
+            <a:pPr algn="l">
+              <a:spcAft>
+                <a:spcPts val="1400"/>
+              </a:spcAft>
+            </a:pPr>
+            <a:r>
+              <a:rPr sz="2800" b="1">
+                <a:solidFill>
+                  <a:srgbClr val="E07B39"/>
+                </a:solidFill>
+                <a:latin typeface="Calibri"/>
+              </a:rPr>
+              <a:t>Temporal split  42.5</a:t>
+            </a:r>
+          </a:p>
+          <a:p>
+            <a:pPr algn="l">
+              <a:spcAft>
+                <a:spcPts val="900"/>
+              </a:spcAft>
+            </a:pPr>
+            <a:r>
+              <a:rPr sz="1800" b="0">
+                <a:solidFill>
+                  <a:srgbClr val="F2F2F2"/>
+                </a:solidFill>
+                <a:latin typeface="Calibri"/>
+              </a:rPr>
+              <a:t>We report the honest temporal number.</a:t>
             </a:r>
           </a:p>
         </p:txBody>
       </p:sp>
       <p:pic>
         <p:nvPicPr>
-          <p:cNvPr id="4" name="Picture 3" descr="06_model_ladder.png"/>
+          <p:cNvPr id="6" name="Picture 5" descr="09_validation_schemes.png"/>
           <p:cNvPicPr>
             <a:picLocks noChangeAspect="1"/>
           </p:cNvPicPr>
@@ -5618,164 +6679,14 @@
         </p:blipFill>
         <p:spPr>
           <a:xfrm>
-            <a:off x="365760" y="1679463"/>
-            <a:ext cx="7589520" cy="3864833"/>
+            <a:off x="5120640" y="1945699"/>
+            <a:ext cx="6583680" cy="4338202"/>
           </a:xfrm>
           <a:prstGeom prst="rect">
             <a:avLst/>
           </a:prstGeom>
         </p:spPr>
       </p:pic>
-      <p:pic>
-        <p:nvPicPr>
-          <p:cNvPr id="5" name="Picture 4" descr="08_history_vs_coldstart.png"/>
-          <p:cNvPicPr>
-            <a:picLocks noChangeAspect="1"/>
-          </p:cNvPicPr>
-          <p:nvPr/>
-        </p:nvPicPr>
-        <p:blipFill>
-          <a:blip r:embed="rId4"/>
-          <a:stretch>
-            <a:fillRect/>
-          </a:stretch>
-        </p:blipFill>
-        <p:spPr>
-          <a:xfrm>
-            <a:off x="8046720" y="1819277"/>
-            <a:ext cx="3840480" cy="2579365"/>
-          </a:xfrm>
-          <a:prstGeom prst="rect">
-            <a:avLst/>
-          </a:prstGeom>
-        </p:spPr>
-      </p:pic>
-      <p:sp>
-        <p:nvSpPr>
-          <p:cNvPr id="6" name="TextBox 5"/>
-          <p:cNvSpPr txBox="1"/>
-          <p:nvPr/>
-        </p:nvSpPr>
-        <p:spPr>
-          <a:xfrm>
-            <a:off x="8046720" y="4754880"/>
-            <a:ext cx="3931920" cy="2011680"/>
-          </a:xfrm>
-          <a:prstGeom prst="rect">
-            <a:avLst/>
-          </a:prstGeom>
-          <a:noFill/>
-        </p:spPr>
-        <p:txBody>
-          <a:bodyPr wrap="square">
-            <a:spAutoFit/>
-          </a:bodyPr>
-          <a:lstStyle/>
-          <a:p>
-            <a:pPr algn="l">
-              <a:spcAft>
-                <a:spcPts val="800"/>
-              </a:spcAft>
-            </a:pPr>
-            <a:r>
-              <a:rPr sz="1600" b="1">
-                <a:solidFill>
-                  <a:srgbClr val="F2F2F2"/>
-                </a:solidFill>
-                <a:latin typeface="Calibri"/>
-              </a:rPr>
-              <a:t>Best: blend of raw + log boosted trees</a:t>
-            </a:r>
-          </a:p>
-          <a:p>
-            <a:pPr algn="l">
-              <a:spcAft>
-                <a:spcPts val="1500"/>
-              </a:spcAft>
-            </a:pPr>
-            <a:r>
-              <a:rPr sz="3000" b="1">
-                <a:solidFill>
-                  <a:srgbClr val="E07B39"/>
-                </a:solidFill>
-                <a:latin typeface="Calibri"/>
-              </a:rPr>
-              <a:t>RMSE 37.6</a:t>
-            </a:r>
-          </a:p>
-          <a:p>
-            <a:pPr algn="l">
-              <a:spcAft>
-                <a:spcPts val="800"/>
-              </a:spcAft>
-            </a:pPr>
-            <a:r>
-              <a:rPr sz="1600" b="0">
-                <a:solidFill>
-                  <a:srgbClr val="F2F2F2"/>
-                </a:solidFill>
-                <a:latin typeface="Calibri"/>
-              </a:rPr>
-              <a:t>−34% vs naive (57.1) · R² 0.57</a:t>
-            </a:r>
-          </a:p>
-          <a:p>
-            <a:pPr algn="l">
-              <a:spcAft>
-                <a:spcPts val="750"/>
-              </a:spcAft>
-            </a:pPr>
-            <a:r>
-              <a:rPr sz="1500" b="0">
-                <a:solidFill>
-                  <a:srgbClr val="A8A8A8"/>
-                </a:solidFill>
-                <a:latin typeface="Calibri"/>
-              </a:rPr>
-              <a:t>Buildings with history: RMSE 20.3</a:t>
-            </a:r>
-          </a:p>
-        </p:txBody>
-      </p:sp>
-      <p:sp>
-        <p:nvSpPr>
-          <p:cNvPr id="7" name="TextBox 6"/>
-          <p:cNvSpPr txBox="1"/>
-          <p:nvPr/>
-        </p:nvSpPr>
-        <p:spPr>
-          <a:xfrm>
-            <a:off x="548640" y="5806440"/>
-            <a:ext cx="7315200" cy="914400"/>
-          </a:xfrm>
-          <a:prstGeom prst="rect">
-            <a:avLst/>
-          </a:prstGeom>
-          <a:noFill/>
-        </p:spPr>
-        <p:txBody>
-          <a:bodyPr wrap="square">
-            <a:spAutoFit/>
-          </a:bodyPr>
-          <a:lstStyle/>
-          <a:p>
-            <a:pPr algn="l">
-              <a:spcAft>
-                <a:spcPts val="750"/>
-              </a:spcAft>
-            </a:pPr>
-            <a:r>
-              <a:rPr sz="1500" b="0">
-                <a:solidFill>
-                  <a:srgbClr val="A8A8A8"/>
-                </a:solidFill>
-                <a:latin typeface="Calibri"/>
-              </a:rPr>
-              <a:t>Linear 46.2 → tree 40.9: interactions matter.  + ENERGY STAR rating, + building history, raw/log blend.</a:t>
-            </a:r>
-          </a:p>
-        </p:txBody>
-      </p:sp>
     </p:spTree>
   </p:cSld>
   <p:clrMapOvr>
@@ -5810,8 +6721,8 @@
         </p:nvSpPr>
         <p:spPr>
           <a:xfrm>
-            <a:off x="548640" y="320040"/>
-            <a:ext cx="10972800" cy="365760"/>
+            <a:off x="10789920" y="6400800"/>
+            <a:ext cx="1188720" cy="365760"/>
           </a:xfrm>
           <a:prstGeom prst="rect">
             <a:avLst/>
@@ -5824,19 +6735,19 @@
           </a:bodyPr>
           <a:lstStyle/>
           <a:p>
-            <a:pPr algn="l">
-              <a:spcAft>
-                <a:spcPts val="650"/>
-              </a:spcAft>
-            </a:pPr>
-            <a:r>
-              <a:rPr sz="1300" b="1">
-                <a:solidFill>
-                  <a:srgbClr val="E07B39"/>
-                </a:solidFill>
-                <a:latin typeface="Calibri"/>
-              </a:rPr>
-              <a:t>WHAT WE LEARNED THE HARD WAY</a:t>
+            <a:pPr algn="r">
+              <a:spcAft>
+                <a:spcPts val="550"/>
+              </a:spcAft>
+            </a:pPr>
+            <a:r>
+              <a:rPr sz="1100" b="0">
+                <a:solidFill>
+                  <a:srgbClr val="A8A8A8"/>
+                </a:solidFill>
+                <a:latin typeface="Calibri"/>
+              </a:rPr>
+              <a:t>7 / 12</a:t>
             </a:r>
           </a:p>
         </p:txBody>
@@ -5849,8 +6760,8 @@
         </p:nvSpPr>
         <p:spPr>
           <a:xfrm>
-            <a:off x="548640" y="640080"/>
-            <a:ext cx="11155680" cy="822960"/>
+            <a:off x="548640" y="320040"/>
+            <a:ext cx="10972800" cy="365760"/>
           </a:xfrm>
           <a:prstGeom prst="rect">
             <a:avLst/>
@@ -5865,17 +6776,17 @@
           <a:p>
             <a:pPr algn="l">
               <a:spcAft>
-                <a:spcPts val="1600"/>
-              </a:spcAft>
-            </a:pPr>
-            <a:r>
-              <a:rPr sz="3200" b="1">
-                <a:solidFill>
-                  <a:srgbClr val="F2F2F2"/>
-                </a:solidFill>
-                <a:latin typeface="Calibri"/>
-              </a:rPr>
-              <a:t>How MATLAB trees treat missing values</a:t>
+                <a:spcPts val="650"/>
+              </a:spcAft>
+            </a:pPr>
+            <a:r>
+              <a:rPr sz="1300" b="1">
+                <a:solidFill>
+                  <a:srgbClr val="E07B39"/>
+                </a:solidFill>
+                <a:latin typeface="Calibri"/>
+              </a:rPr>
+              <a:t>USE OF MACHINE LEARNING</a:t>
             </a:r>
           </a:p>
         </p:txBody>
@@ -5888,8 +6799,8 @@
         </p:nvSpPr>
         <p:spPr>
           <a:xfrm>
-            <a:off x="731520" y="1828800"/>
-            <a:ext cx="5669280" cy="4389120"/>
+            <a:off x="548640" y="640080"/>
+            <a:ext cx="11155680" cy="822960"/>
           </a:xfrm>
           <a:prstGeom prst="rect">
             <a:avLst/>
@@ -5904,63 +6815,79 @@
           <a:p>
             <a:pPr algn="l">
               <a:spcAft>
-                <a:spcPts val="1100"/>
-              </a:spcAft>
-            </a:pPr>
-            <a:r>
-              <a:rPr sz="2200" b="0">
+                <a:spcPts val="1600"/>
+              </a:spcAft>
+            </a:pPr>
+            <a:r>
+              <a:rPr sz="3200" b="1">
                 <a:solidFill>
                   <a:srgbClr val="F2F2F2"/>
                 </a:solidFill>
                 <a:latin typeface="Calibri"/>
               </a:rPr>
-              <a:t>Without surrogate splits, a row missing the split variable stops at that node.</a:t>
-            </a:r>
-          </a:p>
-          <a:p>
-            <a:pPr algn="l">
-              <a:spcAft>
-                <a:spcPts val="1100"/>
-              </a:spcAft>
-            </a:pPr>
-            <a:r>
-              <a:rPr sz="2200" b="0">
-                <a:solidFill>
-                  <a:srgbClr val="F2F2F2"/>
-                </a:solidFill>
-                <a:latin typeface="Calibri"/>
-              </a:rPr>
-              <a:t>ENERGY STAR rating (35% missing) and history (~60% missing) were our strongest features, so those buildings were barely learned.</a:t>
-            </a:r>
-          </a:p>
-          <a:p>
-            <a:pPr algn="l">
-              <a:spcAft>
-                <a:spcPts val="1100"/>
-              </a:spcAft>
-            </a:pPr>
-            <a:r>
-              <a:rPr sz="2200" b="1">
-                <a:solidFill>
-                  <a:srgbClr val="E07B39"/>
-                </a:solidFill>
-                <a:latin typeface="Calibri"/>
-              </a:rPr>
-              <a:t>Fix: encode missing as an out-of-range sentinel (src/treeInputs.m) and keep explicit missing flags.</a:t>
-            </a:r>
-          </a:p>
-        </p:txBody>
-      </p:sp>
-      <p:sp>
-        <p:nvSpPr>
-          <p:cNvPr id="5" name="TextBox 4"/>
+              <a:t>A ladder of 10 models, each answering one question</a:t>
+            </a:r>
+          </a:p>
+        </p:txBody>
+      </p:sp>
+      <p:pic>
+        <p:nvPicPr>
+          <p:cNvPr id="5" name="Picture 4" descr="06_model_ladder.png"/>
+          <p:cNvPicPr>
+            <a:picLocks noChangeAspect="1"/>
+          </p:cNvPicPr>
+          <p:nvPr/>
+        </p:nvPicPr>
+        <p:blipFill>
+          <a:blip r:embed="rId3"/>
+          <a:stretch>
+            <a:fillRect/>
+          </a:stretch>
+        </p:blipFill>
+        <p:spPr>
+          <a:xfrm>
+            <a:off x="365760" y="1679463"/>
+            <a:ext cx="7589520" cy="3864833"/>
+          </a:xfrm>
+          <a:prstGeom prst="rect">
+            <a:avLst/>
+          </a:prstGeom>
+        </p:spPr>
+      </p:pic>
+      <p:pic>
+        <p:nvPicPr>
+          <p:cNvPr id="6" name="Picture 5" descr="08_history_vs_coldstart.png"/>
+          <p:cNvPicPr>
+            <a:picLocks noChangeAspect="1"/>
+          </p:cNvPicPr>
+          <p:nvPr/>
+        </p:nvPicPr>
+        <p:blipFill>
+          <a:blip r:embed="rId4"/>
+          <a:stretch>
+            <a:fillRect/>
+          </a:stretch>
+        </p:blipFill>
+        <p:spPr>
+          <a:xfrm>
+            <a:off x="8046720" y="1819277"/>
+            <a:ext cx="3840480" cy="2579365"/>
+          </a:xfrm>
+          <a:prstGeom prst="rect">
+            <a:avLst/>
+          </a:prstGeom>
+        </p:spPr>
+      </p:pic>
+      <p:sp>
+        <p:nvSpPr>
+          <p:cNvPr id="7" name="TextBox 6"/>
           <p:cNvSpPr txBox="1"/>
           <p:nvPr/>
         </p:nvSpPr>
         <p:spPr>
           <a:xfrm>
-            <a:off x="6675120" y="2377440"/>
-            <a:ext cx="5120640" cy="914400"/>
+            <a:off x="8046720" y="4754880"/>
+            <a:ext cx="3931920" cy="1828800"/>
           </a:xfrm>
           <a:prstGeom prst="rect">
             <a:avLst/>
@@ -5973,33 +6900,65 @@
           </a:bodyPr>
           <a:lstStyle/>
           <a:p>
-            <a:pPr algn="ctr">
-              <a:spcAft>
-                <a:spcPts val="1100"/>
-              </a:spcAft>
-            </a:pPr>
-            <a:r>
-              <a:rPr sz="2200" b="0">
-                <a:solidFill>
-                  <a:srgbClr val="A8A8A8"/>
-                </a:solidFill>
-                <a:latin typeface="Calibri"/>
-              </a:rPr>
-              <a:t>blend RMSE</a:t>
-            </a:r>
-          </a:p>
-        </p:txBody>
-      </p:sp>
-      <p:sp>
-        <p:nvSpPr>
-          <p:cNvPr id="6" name="TextBox 5"/>
+            <a:pPr algn="l">
+              <a:spcAft>
+                <a:spcPts val="800"/>
+              </a:spcAft>
+            </a:pPr>
+            <a:r>
+              <a:rPr sz="1600" b="1">
+                <a:solidFill>
+                  <a:srgbClr val="F2F2F2"/>
+                </a:solidFill>
+                <a:latin typeface="Calibri"/>
+              </a:rPr>
+              <a:t>Best: raw + log boosted-tree blend</a:t>
+            </a:r>
+          </a:p>
+          <a:p>
+            <a:pPr algn="l">
+              <a:spcAft>
+                <a:spcPts val="1500"/>
+              </a:spcAft>
+            </a:pPr>
+            <a:r>
+              <a:rPr sz="3000" b="1">
+                <a:solidFill>
+                  <a:srgbClr val="E07B39"/>
+                </a:solidFill>
+                <a:latin typeface="Calibri"/>
+              </a:rPr>
+              <a:t>RMSE 37.6</a:t>
+            </a:r>
+          </a:p>
+          <a:p>
+            <a:pPr algn="l">
+              <a:spcAft>
+                <a:spcPts val="800"/>
+              </a:spcAft>
+            </a:pPr>
+            <a:r>
+              <a:rPr sz="1600" b="0">
+                <a:solidFill>
+                  <a:srgbClr val="F2F2F2"/>
+                </a:solidFill>
+                <a:latin typeface="Calibri"/>
+              </a:rPr>
+              <a:t>−34% vs naive · R² 0.57</a:t>
+            </a:r>
+          </a:p>
+        </p:txBody>
+      </p:sp>
+      <p:sp>
+        <p:nvSpPr>
+          <p:cNvPr id="8" name="TextBox 7"/>
           <p:cNvSpPr txBox="1"/>
           <p:nvPr/>
         </p:nvSpPr>
         <p:spPr>
           <a:xfrm>
-            <a:off x="6675120" y="2926080"/>
-            <a:ext cx="5120640" cy="1463040"/>
+            <a:off x="548640" y="5806440"/>
+            <a:ext cx="7315200" cy="731520"/>
           </a:xfrm>
           <a:prstGeom prst="rect">
             <a:avLst/>
@@ -6012,58 +6971,19 @@
           </a:bodyPr>
           <a:lstStyle/>
           <a:p>
-            <a:pPr algn="ctr">
-              <a:spcAft>
-                <a:spcPts val="3000"/>
-              </a:spcAft>
-            </a:pPr>
-            <a:r>
-              <a:rPr sz="6000" b="1">
-                <a:solidFill>
-                  <a:srgbClr val="E07B39"/>
-                </a:solidFill>
-                <a:latin typeface="Calibri"/>
-              </a:rPr>
-              <a:t>46.8  →  37.6</a:t>
-            </a:r>
-          </a:p>
-        </p:txBody>
-      </p:sp>
-      <p:sp>
-        <p:nvSpPr>
-          <p:cNvPr id="7" name="TextBox 6"/>
-          <p:cNvSpPr txBox="1"/>
-          <p:nvPr/>
-        </p:nvSpPr>
-        <p:spPr>
-          <a:xfrm>
-            <a:off x="6675120" y="4389120"/>
-            <a:ext cx="5120640" cy="914400"/>
-          </a:xfrm>
-          <a:prstGeom prst="rect">
-            <a:avLst/>
-          </a:prstGeom>
-          <a:noFill/>
-        </p:spPr>
-        <p:txBody>
-          <a:bodyPr wrap="square">
-            <a:spAutoFit/>
-          </a:bodyPr>
-          <a:lstStyle/>
-          <a:p>
-            <a:pPr algn="ctr">
-              <a:spcAft>
-                <a:spcPts val="900"/>
-              </a:spcAft>
-            </a:pPr>
-            <a:r>
-              <a:rPr sz="1800" b="0">
+            <a:pPr algn="l">
+              <a:spcAft>
+                <a:spcPts val="800"/>
+              </a:spcAft>
+            </a:pPr>
+            <a:r>
+              <a:rPr sz="1600" b="0">
                 <a:solidFill>
                   <a:srgbClr val="A8A8A8"/>
                 </a:solidFill>
                 <a:latin typeface="Calibri"/>
               </a:rPr>
-              <a:t>first full run → after the fix</a:t>
+              <a:t>Linear 46.2 → single tree 40.9 · buildings with history: RMSE 20</a:t>
             </a:r>
           </a:p>
         </p:txBody>
@@ -6102,8 +7022,8 @@
         </p:nvSpPr>
         <p:spPr>
           <a:xfrm>
-            <a:off x="548640" y="320040"/>
-            <a:ext cx="10972800" cy="365760"/>
+            <a:off x="10789920" y="6400800"/>
+            <a:ext cx="1188720" cy="365760"/>
           </a:xfrm>
           <a:prstGeom prst="rect">
             <a:avLst/>
@@ -6116,19 +7036,19 @@
           </a:bodyPr>
           <a:lstStyle/>
           <a:p>
-            <a:pPr algn="l">
-              <a:spcAft>
-                <a:spcPts val="650"/>
-              </a:spcAft>
-            </a:pPr>
-            <a:r>
-              <a:rPr sz="1300" b="1">
-                <a:solidFill>
-                  <a:srgbClr val="E07B39"/>
-                </a:solidFill>
-                <a:latin typeface="Calibri"/>
-              </a:rPr>
-              <a:t>INTERPRETABILITY</a:t>
+            <a:pPr algn="r">
+              <a:spcAft>
+                <a:spcPts val="550"/>
+              </a:spcAft>
+            </a:pPr>
+            <a:r>
+              <a:rPr sz="1100" b="0">
+                <a:solidFill>
+                  <a:srgbClr val="A8A8A8"/>
+                </a:solidFill>
+                <a:latin typeface="Calibri"/>
+              </a:rPr>
+              <a:t>8 / 12</a:t>
             </a:r>
           </a:p>
         </p:txBody>
@@ -6141,8 +7061,8 @@
         </p:nvSpPr>
         <p:spPr>
           <a:xfrm>
-            <a:off x="548640" y="640080"/>
-            <a:ext cx="11155680" cy="822960"/>
+            <a:off x="548640" y="320040"/>
+            <a:ext cx="10972800" cy="365760"/>
           </a:xfrm>
           <a:prstGeom prst="rect">
             <a:avLst/>
@@ -6157,55 +7077,31 @@
           <a:p>
             <a:pPr algn="l">
               <a:spcAft>
-                <a:spcPts val="1600"/>
-              </a:spcAft>
-            </a:pPr>
-            <a:r>
-              <a:rPr sz="3200" b="1">
-                <a:solidFill>
-                  <a:srgbClr val="F2F2F2"/>
-                </a:solidFill>
-                <a:latin typeface="Calibri"/>
-              </a:rPr>
-              <a:t>What drives energy use</a:t>
-            </a:r>
-          </a:p>
-        </p:txBody>
-      </p:sp>
-      <p:pic>
-        <p:nvPicPr>
-          <p:cNvPr id="4" name="Picture 3" descr="11_partial_dependence.png"/>
-          <p:cNvPicPr>
-            <a:picLocks noChangeAspect="1"/>
-          </p:cNvPicPr>
-          <p:nvPr/>
-        </p:nvPicPr>
-        <p:blipFill>
-          <a:blip r:embed="rId3"/>
-          <a:stretch>
-            <a:fillRect/>
-          </a:stretch>
-        </p:blipFill>
-        <p:spPr>
-          <a:xfrm>
-            <a:off x="365760" y="1605752"/>
-            <a:ext cx="11430000" cy="3829376"/>
-          </a:xfrm>
-          <a:prstGeom prst="rect">
-            <a:avLst/>
-          </a:prstGeom>
-        </p:spPr>
-      </p:pic>
-      <p:sp>
-        <p:nvSpPr>
-          <p:cNvPr id="5" name="TextBox 4"/>
+                <a:spcPts val="650"/>
+              </a:spcAft>
+            </a:pPr>
+            <a:r>
+              <a:rPr sz="1300" b="1">
+                <a:solidFill>
+                  <a:srgbClr val="E07B39"/>
+                </a:solidFill>
+                <a:latin typeface="Calibri"/>
+              </a:rPr>
+              <a:t>WHAT WE LEARNED THE HARD WAY</a:t>
+            </a:r>
+          </a:p>
+        </p:txBody>
+      </p:sp>
+      <p:sp>
+        <p:nvSpPr>
+          <p:cNvPr id="4" name="TextBox 3"/>
           <p:cNvSpPr txBox="1"/>
           <p:nvPr/>
         </p:nvSpPr>
         <p:spPr>
           <a:xfrm>
-            <a:off x="548640" y="5577840"/>
-            <a:ext cx="11155680" cy="1188720"/>
+            <a:off x="548640" y="640080"/>
+            <a:ext cx="11155680" cy="822960"/>
           </a:xfrm>
           <a:prstGeom prst="rect">
             <a:avLst/>
@@ -6220,33 +7116,205 @@
           <a:p>
             <a:pPr algn="l">
               <a:spcAft>
-                <a:spcPts val="850"/>
-              </a:spcAft>
-            </a:pPr>
-            <a:r>
-              <a:rPr sz="1700" b="0">
+                <a:spcPts val="1600"/>
+              </a:spcAft>
+            </a:pPr>
+            <a:r>
+              <a:rPr sz="3200" b="1">
                 <a:solidFill>
                   <a:srgbClr val="F2F2F2"/>
                 </a:solidFill>
                 <a:latin typeface="Calibri"/>
               </a:rPr>
-              <a:t>Higher ENERGY STAR score → lower EUI; past use predicts future use. Top drivers: facility type, ENERGY STAR rating, previous-year EUI, floor area.</a:t>
-            </a:r>
-          </a:p>
+              <a:t>A MATLAB-specific lesson: missing values in trees</a:t>
+            </a:r>
+          </a:p>
+        </p:txBody>
+      </p:sp>
+      <p:sp>
+        <p:nvSpPr>
+          <p:cNvPr id="5" name="TextBox 4"/>
+          <p:cNvSpPr txBox="1"/>
+          <p:nvPr/>
+        </p:nvSpPr>
+        <p:spPr>
+          <a:xfrm>
+            <a:off x="731520" y="1828800"/>
+            <a:ext cx="5669280" cy="4389120"/>
+          </a:xfrm>
+          <a:prstGeom prst="rect">
+            <a:avLst/>
+          </a:prstGeom>
+          <a:noFill/>
+        </p:spPr>
+        <p:txBody>
+          <a:bodyPr wrap="square">
+            <a:spAutoFit/>
+          </a:bodyPr>
+          <a:lstStyle/>
           <a:p>
             <a:pPr algn="l">
               <a:spcAft>
-                <a:spcPts val="750"/>
-              </a:spcAft>
-            </a:pPr>
-            <a:r>
-              <a:rPr sz="1500" b="0">
+                <a:spcPts val="1100"/>
+              </a:spcAft>
+            </a:pPr>
+            <a:r>
+              <a:rPr sz="2200" b="0">
+                <a:solidFill>
+                  <a:srgbClr val="F2F2F2"/>
+                </a:solidFill>
+                <a:latin typeface="Calibri"/>
+              </a:rPr>
+              <a:t>Without surrogate splits, a row missing the split variable stops at that node.</a:t>
+            </a:r>
+          </a:p>
+          <a:p>
+            <a:pPr algn="l">
+              <a:spcAft>
+                <a:spcPts val="1100"/>
+              </a:spcAft>
+            </a:pPr>
+            <a:r>
+              <a:rPr sz="2200" b="0">
+                <a:solidFill>
+                  <a:srgbClr val="F2F2F2"/>
+                </a:solidFill>
+                <a:latin typeface="Calibri"/>
+              </a:rPr>
+              <a:t>Our first run barely learned from buildings without a rating.</a:t>
+            </a:r>
+          </a:p>
+          <a:p>
+            <a:pPr algn="l">
+              <a:spcAft>
+                <a:spcPts val="1100"/>
+              </a:spcAft>
+            </a:pPr>
+            <a:r>
+              <a:rPr sz="2200" b="1">
+                <a:solidFill>
+                  <a:srgbClr val="E07B39"/>
+                </a:solidFill>
+                <a:latin typeface="Calibri"/>
+              </a:rPr>
+              <a:t>Fix: encode missing values explicitly (src/treeInputs.m)</a:t>
+            </a:r>
+          </a:p>
+        </p:txBody>
+      </p:sp>
+      <p:sp>
+        <p:nvSpPr>
+          <p:cNvPr id="6" name="TextBox 5"/>
+          <p:cNvSpPr txBox="1"/>
+          <p:nvPr/>
+        </p:nvSpPr>
+        <p:spPr>
+          <a:xfrm>
+            <a:off x="6675120" y="2377440"/>
+            <a:ext cx="5120640" cy="914400"/>
+          </a:xfrm>
+          <a:prstGeom prst="rect">
+            <a:avLst/>
+          </a:prstGeom>
+          <a:noFill/>
+        </p:spPr>
+        <p:txBody>
+          <a:bodyPr wrap="square">
+            <a:spAutoFit/>
+          </a:bodyPr>
+          <a:lstStyle/>
+          <a:p>
+            <a:pPr algn="ctr">
+              <a:spcAft>
+                <a:spcPts val="1100"/>
+              </a:spcAft>
+            </a:pPr>
+            <a:r>
+              <a:rPr sz="2200" b="0">
                 <a:solidFill>
                   <a:srgbClr val="A8A8A8"/>
                 </a:solidFill>
                 <a:latin typeface="Calibri"/>
               </a:rPr>
-              <a:t>Honest caveat: weather is recorded per state and year, so once the state is known the degree-day features add little.</a:t>
+              <a:t>blend RMSE</a:t>
+            </a:r>
+          </a:p>
+        </p:txBody>
+      </p:sp>
+      <p:sp>
+        <p:nvSpPr>
+          <p:cNvPr id="7" name="TextBox 6"/>
+          <p:cNvSpPr txBox="1"/>
+          <p:nvPr/>
+        </p:nvSpPr>
+        <p:spPr>
+          <a:xfrm>
+            <a:off x="6675120" y="2926080"/>
+            <a:ext cx="5120640" cy="1463040"/>
+          </a:xfrm>
+          <a:prstGeom prst="rect">
+            <a:avLst/>
+          </a:prstGeom>
+          <a:noFill/>
+        </p:spPr>
+        <p:txBody>
+          <a:bodyPr wrap="square">
+            <a:spAutoFit/>
+          </a:bodyPr>
+          <a:lstStyle/>
+          <a:p>
+            <a:pPr algn="ctr">
+              <a:spcAft>
+                <a:spcPts val="3000"/>
+              </a:spcAft>
+            </a:pPr>
+            <a:r>
+              <a:rPr sz="6000" b="1">
+                <a:solidFill>
+                  <a:srgbClr val="E07B39"/>
+                </a:solidFill>
+                <a:latin typeface="Calibri"/>
+              </a:rPr>
+              <a:t>46.8  →  37.6</a:t>
+            </a:r>
+          </a:p>
+        </p:txBody>
+      </p:sp>
+      <p:sp>
+        <p:nvSpPr>
+          <p:cNvPr id="8" name="TextBox 7"/>
+          <p:cNvSpPr txBox="1"/>
+          <p:nvPr/>
+        </p:nvSpPr>
+        <p:spPr>
+          <a:xfrm>
+            <a:off x="6675120" y="4389120"/>
+            <a:ext cx="5120640" cy="914400"/>
+          </a:xfrm>
+          <a:prstGeom prst="rect">
+            <a:avLst/>
+          </a:prstGeom>
+          <a:noFill/>
+        </p:spPr>
+        <p:txBody>
+          <a:bodyPr wrap="square">
+            <a:spAutoFit/>
+          </a:bodyPr>
+          <a:lstStyle/>
+          <a:p>
+            <a:pPr algn="ctr">
+              <a:spcAft>
+                <a:spcPts val="900"/>
+              </a:spcAft>
+            </a:pPr>
+            <a:r>
+              <a:rPr sz="1800" b="0">
+                <a:solidFill>
+                  <a:srgbClr val="A8A8A8"/>
+                </a:solidFill>
+                <a:latin typeface="Calibri"/>
+              </a:rPr>
+              <a:t>first full run → after the fix</a:t>
             </a:r>
           </a:p>
         </p:txBody>
@@ -6285,8 +7353,8 @@
         </p:nvSpPr>
         <p:spPr>
           <a:xfrm>
-            <a:off x="548640" y="320040"/>
-            <a:ext cx="10972800" cy="365760"/>
+            <a:off x="10789920" y="6400800"/>
+            <a:ext cx="1188720" cy="365760"/>
           </a:xfrm>
           <a:prstGeom prst="rect">
             <a:avLst/>
@@ -6299,19 +7367,19 @@
           </a:bodyPr>
           <a:lstStyle/>
           <a:p>
-            <a:pPr algn="l">
-              <a:spcAft>
-                <a:spcPts val="650"/>
-              </a:spcAft>
-            </a:pPr>
-            <a:r>
-              <a:rPr sz="1300" b="1">
-                <a:solidFill>
-                  <a:srgbClr val="E07B39"/>
-                </a:solidFill>
-                <a:latin typeface="Calibri"/>
-              </a:rPr>
-              <a:t>IMPACT</a:t>
+            <a:pPr algn="r">
+              <a:spcAft>
+                <a:spcPts val="550"/>
+              </a:spcAft>
+            </a:pPr>
+            <a:r>
+              <a:rPr sz="1100" b="0">
+                <a:solidFill>
+                  <a:srgbClr val="A8A8A8"/>
+                </a:solidFill>
+                <a:latin typeface="Calibri"/>
+              </a:rPr>
+              <a:t>9 / 12</a:t>
             </a:r>
           </a:p>
         </p:txBody>
@@ -6324,8 +7392,8 @@
         </p:nvSpPr>
         <p:spPr>
           <a:xfrm>
-            <a:off x="548640" y="640080"/>
-            <a:ext cx="11155680" cy="822960"/>
+            <a:off x="548640" y="320040"/>
+            <a:ext cx="10972800" cy="365760"/>
           </a:xfrm>
           <a:prstGeom prst="rect">
             <a:avLst/>
@@ -6340,17 +7408,17 @@
           <a:p>
             <a:pPr algn="l">
               <a:spcAft>
-                <a:spcPts val="1600"/>
-              </a:spcAft>
-            </a:pPr>
-            <a:r>
-              <a:rPr sz="3200" b="1">
-                <a:solidFill>
-                  <a:srgbClr val="F2F2F2"/>
-                </a:solidFill>
-                <a:latin typeface="Calibri"/>
-              </a:rPr>
-              <a:t>From prediction to action: the retrofit shortlist</a:t>
+                <a:spcPts val="650"/>
+              </a:spcAft>
+            </a:pPr>
+            <a:r>
+              <a:rPr sz="1300" b="1">
+                <a:solidFill>
+                  <a:srgbClr val="E07B39"/>
+                </a:solidFill>
+                <a:latin typeface="Calibri"/>
+              </a:rPr>
+              <a:t>INTERPRETABILITY</a:t>
             </a:r>
           </a:p>
         </p:txBody>
@@ -6363,8 +7431,8 @@
         </p:nvSpPr>
         <p:spPr>
           <a:xfrm>
-            <a:off x="548640" y="1737360"/>
-            <a:ext cx="4389120" cy="4846320"/>
+            <a:off x="548640" y="640080"/>
+            <a:ext cx="11155680" cy="822960"/>
           </a:xfrm>
           <a:prstGeom prst="rect">
             <a:avLst/>
@@ -6379,88 +7447,24 @@
           <a:p>
             <a:pPr algn="l">
               <a:spcAft>
-                <a:spcPts val="900"/>
-              </a:spcAft>
-            </a:pPr>
-            <a:r>
-              <a:rPr sz="1800" b="0">
+                <a:spcPts val="1600"/>
+              </a:spcAft>
+            </a:pPr>
+            <a:r>
+              <a:rPr sz="3200" b="1">
                 <a:solidFill>
                   <a:srgbClr val="F2F2F2"/>
                 </a:solidFill>
                 <a:latin typeface="Calibri"/>
               </a:rPr>
-              <a:t>A cold-start model predicts what a typical building of the same type, size, age and climate should use.</a:t>
-            </a:r>
-          </a:p>
-          <a:p>
-            <a:pPr algn="l">
-              <a:spcAft>
-                <a:spcPts val="900"/>
-              </a:spcAft>
-            </a:pPr>
-            <a:r>
-              <a:rPr sz="1800" b="0">
-                <a:solidFill>
-                  <a:srgbClr val="F2F2F2"/>
-                </a:solidFill>
-                <a:latin typeface="Calibri"/>
-              </a:rPr>
-              <a:t>Candidates: top 5% excess within each facility type, ranked by excess EUI × floor area.</a:t>
-            </a:r>
-          </a:p>
-          <a:p>
-            <a:pPr algn="l">
-              <a:spcAft>
-                <a:spcPts val="1500"/>
-              </a:spcAft>
-            </a:pPr>
-            <a:r>
-              <a:rPr sz="3000" b="1">
-                <a:solidFill>
-                  <a:srgbClr val="E07B39"/>
-                </a:solidFill>
-                <a:latin typeface="Calibri"/>
-              </a:rPr>
-              <a:t>1,123 buildings</a:t>
-            </a:r>
-          </a:p>
-          <a:p>
-            <a:pPr algn="l">
-              <a:spcAft>
-                <a:spcPts val="1000"/>
-              </a:spcAft>
-            </a:pPr>
-            <a:r>
-              <a:rPr sz="2000" b="1">
-                <a:solidFill>
-                  <a:srgbClr val="F2F2F2"/>
-                </a:solidFill>
-                <a:latin typeface="Calibri"/>
-              </a:rPr>
-              <a:t>1.55 × 10¹⁰ kBtu/yr above expected</a:t>
-            </a:r>
-          </a:p>
-          <a:p>
-            <a:pPr algn="l">
-              <a:spcAft>
-                <a:spcPts val="900"/>
-              </a:spcAft>
-            </a:pPr>
-            <a:r>
-              <a:rPr sz="1800" b="0">
-                <a:solidFill>
-                  <a:srgbClr val="A8A8A8"/>
-                </a:solidFill>
-                <a:latin typeface="Calibri"/>
-              </a:rPr>
-              <a:t>5.3% of all energy used, concentrated in ~5% of buildings</a:t>
+              <a:t>What the model learned</a:t>
             </a:r>
           </a:p>
         </p:txBody>
       </p:sp>
       <p:pic>
         <p:nvPicPr>
-          <p:cNvPr id="5" name="Picture 4" descr="12_retrofit_shortlist.png"/>
+          <p:cNvPr id="5" name="Picture 4" descr="11_partial_dependence.png"/>
           <p:cNvPicPr>
             <a:picLocks noChangeAspect="1"/>
           </p:cNvPicPr>
@@ -6474,14 +7478,69 @@
         </p:blipFill>
         <p:spPr>
           <a:xfrm>
-            <a:off x="5029200" y="2123169"/>
-            <a:ext cx="6858000" cy="3983262"/>
+            <a:off x="365760" y="1605752"/>
+            <a:ext cx="11430000" cy="3829376"/>
           </a:xfrm>
           <a:prstGeom prst="rect">
             <a:avLst/>
           </a:prstGeom>
         </p:spPr>
       </p:pic>
+      <p:sp>
+        <p:nvSpPr>
+          <p:cNvPr id="6" name="TextBox 5"/>
+          <p:cNvSpPr txBox="1"/>
+          <p:nvPr/>
+        </p:nvSpPr>
+        <p:spPr>
+          <a:xfrm>
+            <a:off x="548640" y="5577840"/>
+            <a:ext cx="11155680" cy="1097280"/>
+          </a:xfrm>
+          <a:prstGeom prst="rect">
+            <a:avLst/>
+          </a:prstGeom>
+          <a:noFill/>
+        </p:spPr>
+        <p:txBody>
+          <a:bodyPr wrap="square">
+            <a:spAutoFit/>
+          </a:bodyPr>
+          <a:lstStyle/>
+          <a:p>
+            <a:pPr algn="l">
+              <a:spcAft>
+                <a:spcPts val="900"/>
+              </a:spcAft>
+            </a:pPr>
+            <a:r>
+              <a:rPr sz="1800" b="1">
+                <a:solidFill>
+                  <a:srgbClr val="F2F2F2"/>
+                </a:solidFill>
+                <a:latin typeface="Calibri"/>
+              </a:rPr>
+              <a:t>Higher ENERGY STAR score → lower energy use · past use predicts future use</a:t>
+            </a:r>
+          </a:p>
+          <a:p>
+            <a:pPr algn="l">
+              <a:spcAft>
+                <a:spcPts val="750"/>
+              </a:spcAft>
+            </a:pPr>
+            <a:r>
+              <a:rPr sz="1500" b="0">
+                <a:solidFill>
+                  <a:srgbClr val="A8A8A8"/>
+                </a:solidFill>
+                <a:latin typeface="Calibri"/>
+              </a:rPr>
+              <a:t>Honest caveat: weather is recorded per state and year, so once the state is known the degree-day features add little.</a:t>
+            </a:r>
+          </a:p>
+        </p:txBody>
+      </p:sp>
     </p:spTree>
   </p:cSld>
   <p:clrMapOvr>

</xml_diff>